<commit_message>
Update PPTX binary and remove redundant Google Gemini doc
</commit_message>
<xml_diff>
--- a/40_Projects/Work/Safe_AI/Next_Gen_AI_Security_Strategy.pptx
+++ b/40_Projects/Work/Safe_AI/Next_Gen_AI_Security_Strategy.pptx
@@ -17,7 +17,6 @@
     <p:sldId id="265" r:id="rId16"/>
     <p:sldId id="266" r:id="rId17"/>
     <p:sldId id="267" r:id="rId18"/>
-    <p:sldId id="268" r:id="rId19"/>
   </p:sldIdLst>
   <p:sldSz cx="9144000" cy="6858000" type="screen4x3"/>
   <p:notesSz cx="6858000" cy="9144000"/>
@@ -3096,7 +3095,7 @@
     <p:bg>
       <p:bgPr>
         <a:solidFill>
-          <a:srgbClr val="1F1F1F"/>
+          <a:srgbClr val="0F172A"/>
         </a:solidFill>
         <a:effectLst/>
       </p:bgPr>
@@ -3108,16 +3107,118 @@
         <p:nvPr/>
       </p:nvGrpSpPr>
       <p:grpSpPr/>
-      <p:sp>
-        <p:nvSpPr>
-          <p:cNvPr id="2" name="TextBox 1"/>
+      <p:pic>
+        <p:nvPicPr>
+          <p:cNvPr id="2" name="Picture 1" descr="ai_security_dashboard_futuristic_1778200297333.png"/>
+          <p:cNvPicPr>
+            <a:picLocks noChangeAspect="1"/>
+          </p:cNvPicPr>
+          <p:nvPr/>
+        </p:nvPicPr>
+        <p:blipFill>
+          <a:blip r:embed="rId2"/>
+          <a:stretch>
+            <a:fillRect/>
+          </a:stretch>
+        </p:blipFill>
+        <p:spPr>
+          <a:xfrm>
+            <a:off x="4572000" y="0"/>
+            <a:ext cx="6858000" cy="6858000"/>
+          </a:xfrm>
+          <a:prstGeom prst="rect">
+            <a:avLst/>
+          </a:prstGeom>
+        </p:spPr>
+      </p:pic>
+      <p:sp>
+        <p:nvSpPr>
+          <p:cNvPr id="3" name="Rectangle 2"/>
+          <p:cNvSpPr/>
+          <p:nvPr/>
+        </p:nvSpPr>
+        <p:spPr>
+          <a:xfrm>
+            <a:off x="0" y="0"/>
+            <a:ext cx="5029200" cy="6858000"/>
+          </a:xfrm>
+          <a:prstGeom prst="rect">
+            <a:avLst/>
+          </a:prstGeom>
+          <a:solidFill>
+            <a:srgbClr val="0F172A"/>
+          </a:solidFill>
+          <a:ln>
+            <a:noFill/>
+          </a:ln>
+        </p:spPr>
+        <p:style>
+          <a:lnRef idx="1">
+            <a:schemeClr val="accent1"/>
+          </a:lnRef>
+          <a:fillRef idx="3">
+            <a:schemeClr val="accent1"/>
+          </a:fillRef>
+          <a:effectRef idx="2">
+            <a:schemeClr val="accent1"/>
+          </a:effectRef>
+          <a:fontRef idx="minor">
+            <a:schemeClr val="lt1"/>
+          </a:fontRef>
+        </p:style>
+        <p:txBody>
+          <a:bodyPr rtlCol="0" anchor="ctr"/>
+          <a:lstStyle/>
+          <a:p>
+            <a:pPr algn="ctr"/>
+          </a:p>
+        </p:txBody>
+      </p:sp>
+      <p:sp>
+        <p:nvSpPr>
+          <p:cNvPr id="4" name="TextBox 3"/>
           <p:cNvSpPr txBox="1"/>
           <p:nvPr/>
         </p:nvSpPr>
         <p:spPr>
           <a:xfrm>
-            <a:off x="457200" y="2743200"/>
-            <a:ext cx="8229600" cy="1371600"/>
+            <a:off x="457200" y="2286000"/>
+            <a:ext cx="4114800" cy="1828800"/>
+          </a:xfrm>
+          <a:prstGeom prst="rect">
+            <a:avLst/>
+          </a:prstGeom>
+          <a:noFill/>
+        </p:spPr>
+        <p:txBody>
+          <a:bodyPr wrap="square">
+            <a:spAutoFit/>
+          </a:bodyPr>
+          <a:lstStyle/>
+          <a:p>
+            <a:pPr algn="l">
+              <a:defRPr b="1" sz="4000">
+                <a:solidFill>
+                  <a:srgbClr val="FFFFFF"/>
+                </a:solidFill>
+              </a:defRPr>
+            </a:pPr>
+            <a:r>
+              <a:t>Next-Gen AI Security Strategy</a:t>
+            </a:r>
+          </a:p>
+        </p:txBody>
+      </p:sp>
+      <p:sp>
+        <p:nvSpPr>
+          <p:cNvPr id="5" name="TextBox 4"/>
+          <p:cNvSpPr txBox="1"/>
+          <p:nvPr/>
+        </p:nvSpPr>
+        <p:spPr>
+          <a:xfrm>
+            <a:off x="457200" y="4114800"/>
+            <a:ext cx="4114800" cy="914400"/>
           </a:xfrm>
           <a:prstGeom prst="rect">
             <a:avLst/>
@@ -3131,44 +3232,9 @@
           <a:lstStyle/>
           <a:p>
             <a:pPr algn="l">
-              <a:defRPr b="1" sz="4400">
-                <a:solidFill>
-                  <a:srgbClr val="FFFFFF"/>
-                </a:solidFill>
-              </a:defRPr>
-            </a:pPr>
-            <a:r>
-              <a:t>Next-Gen AI Security Strategy</a:t>
-            </a:r>
-          </a:p>
-        </p:txBody>
-      </p:sp>
-      <p:sp>
-        <p:nvSpPr>
-          <p:cNvPr id="3" name="TextBox 2"/>
-          <p:cNvSpPr txBox="1"/>
-          <p:nvPr/>
-        </p:nvSpPr>
-        <p:spPr>
-          <a:xfrm>
-            <a:off x="457200" y="4114800"/>
-            <a:ext cx="8229600" cy="914400"/>
-          </a:xfrm>
-          <a:prstGeom prst="rect">
-            <a:avLst/>
-          </a:prstGeom>
-          <a:noFill/>
-        </p:spPr>
-        <p:txBody>
-          <a:bodyPr wrap="none">
-            <a:spAutoFit/>
-          </a:bodyPr>
-          <a:lstStyle/>
-          <a:p>
-            <a:pPr algn="l">
-              <a:defRPr sz="2000">
-                <a:solidFill>
-                  <a:srgbClr val="7B3CE9"/>
+              <a:defRPr sz="1800">
+                <a:solidFill>
+                  <a:srgbClr val="06B6D4"/>
                 </a:solidFill>
               </a:defRPr>
             </a:pPr>
@@ -3270,14 +3336,14 @@
           <a:lstStyle/>
           <a:p>
             <a:pPr>
-              <a:defRPr b="1" sz="2800">
-                <a:solidFill>
-                  <a:srgbClr val="1F1F1F"/>
+              <a:defRPr b="1" sz="2400">
+                <a:solidFill>
+                  <a:srgbClr val="0F172A"/>
                 </a:solidFill>
               </a:defRPr>
             </a:pPr>
             <a:r>
-              <a:t>U+ Safe AI 엔드투엔드 보안 프로세스</a:t>
+              <a:t>상품화 로드맵 (5대 라인업)</a:t>
             </a:r>
           </a:p>
         </p:txBody>
@@ -3299,20 +3365,20 @@
           <a:noFill/>
         </p:spPr>
         <p:txBody>
-          <a:bodyPr wrap="none">
+          <a:bodyPr wrap="square">
             <a:spAutoFit/>
           </a:bodyPr>
           <a:lstStyle/>
           <a:p>
             <a:pPr>
-              <a:defRPr sz="1800">
+              <a:defRPr sz="1300">
                 <a:solidFill>
                   <a:srgbClr val="1F1F1F"/>
                 </a:solidFill>
               </a:defRPr>
             </a:pPr>
             <a:r>
-              <a:t>• 0. AI-SPM: 인프라 및 모델 자산의 안전성 상시 점검</a:t>
+              <a:t>• 1. AI-Sanitizer: 자산 완전 파기 및 증명 솔루션</a:t>
             </a:r>
           </a:p>
         </p:txBody>
@@ -3325,7 +3391,7 @@
         </p:nvSpPr>
         <p:spPr>
           <a:xfrm>
-            <a:off x="457200" y="1463040"/>
+            <a:off x="457200" y="1417319"/>
             <a:ext cx="8229600" cy="457200"/>
           </a:xfrm>
           <a:prstGeom prst="rect">
@@ -3334,20 +3400,20 @@
           <a:noFill/>
         </p:spPr>
         <p:txBody>
-          <a:bodyPr wrap="none">
+          <a:bodyPr wrap="square">
             <a:spAutoFit/>
           </a:bodyPr>
           <a:lstStyle/>
           <a:p>
             <a:pPr>
-              <a:defRPr sz="1800">
+              <a:defRPr sz="1300">
                 <a:solidFill>
                   <a:srgbClr val="1F1F1F"/>
                 </a:solidFill>
               </a:defRPr>
             </a:pPr>
             <a:r>
-              <a:t>• 1. Semantic DLP: 사용자 요청의 문맥 분석 및 1차 필터링</a:t>
+              <a:t>• 2. AI Lifecycle Governance: 전사 자산 관리 대시보드</a:t>
             </a:r>
           </a:p>
         </p:txBody>
@@ -3360,7 +3426,7 @@
         </p:nvSpPr>
         <p:spPr>
           <a:xfrm>
-            <a:off x="457200" y="1828800"/>
+            <a:off x="457200" y="1737360"/>
             <a:ext cx="8229600" cy="457200"/>
           </a:xfrm>
           <a:prstGeom prst="rect">
@@ -3369,20 +3435,20 @@
           <a:noFill/>
         </p:spPr>
         <p:txBody>
-          <a:bodyPr wrap="none">
+          <a:bodyPr wrap="square">
             <a:spAutoFit/>
           </a:bodyPr>
           <a:lstStyle/>
           <a:p>
             <a:pPr>
-              <a:defRPr sz="1800">
+              <a:defRPr sz="1300">
                 <a:solidFill>
                   <a:srgbClr val="1F1F1F"/>
                 </a:solidFill>
               </a:defRPr>
             </a:pPr>
             <a:r>
-              <a:t>• 2. AI-DSPM: RAG 참조 데이터의 민감 정보 마스킹 및 오염 차단</a:t>
+              <a:t>• 3. Model Memory Leakage Scanner: 유출 리스크 자동 감사기</a:t>
             </a:r>
           </a:p>
         </p:txBody>
@@ -3395,7 +3461,7 @@
         </p:nvSpPr>
         <p:spPr>
           <a:xfrm>
-            <a:off x="457200" y="2194560"/>
+            <a:off x="457200" y="2057400"/>
             <a:ext cx="8229600" cy="457200"/>
           </a:xfrm>
           <a:prstGeom prst="rect">
@@ -3404,20 +3470,20 @@
           <a:noFill/>
         </p:spPr>
         <p:txBody>
-          <a:bodyPr wrap="none">
+          <a:bodyPr wrap="square">
             <a:spAutoFit/>
           </a:bodyPr>
           <a:lstStyle/>
           <a:p>
             <a:pPr>
-              <a:defRPr sz="1800">
+              <a:defRPr sz="1300">
                 <a:solidFill>
                   <a:srgbClr val="1F1F1F"/>
                 </a:solidFill>
               </a:defRPr>
             </a:pPr>
             <a:r>
-              <a:t>• 3. Agent-SPM: AI의 추론 과정(CoT) 실시간 감시 및 행위 통제</a:t>
+              <a:t>• 4. AI Compliance-as-a-Service: 글로벌 규제 대응 자동화 패키지</a:t>
             </a:r>
           </a:p>
         </p:txBody>
@@ -3430,7 +3496,7 @@
         </p:nvSpPr>
         <p:spPr>
           <a:xfrm>
-            <a:off x="457200" y="2560320"/>
+            <a:off x="457200" y="2377440"/>
             <a:ext cx="8229600" cy="457200"/>
           </a:xfrm>
           <a:prstGeom prst="rect">
@@ -3439,20 +3505,20 @@
           <a:noFill/>
         </p:spPr>
         <p:txBody>
-          <a:bodyPr wrap="none">
+          <a:bodyPr wrap="square">
             <a:spAutoFit/>
           </a:bodyPr>
           <a:lstStyle/>
           <a:p>
             <a:pPr>
-              <a:defRPr sz="1800">
+              <a:defRPr sz="1300">
                 <a:solidFill>
                   <a:srgbClr val="1F1F1F"/>
                 </a:solidFill>
               </a:defRPr>
             </a:pPr>
             <a:r>
-              <a:t>• 4. Compliance XAI: 전수 로깅 및 규제 대응 보고서 자동 생성</a:t>
+              <a:t>• 5. AI Cyber Insurance Linkage: 보안 점수 기반 보험료 할인 연계 상품</a:t>
             </a:r>
           </a:p>
         </p:txBody>
@@ -3549,14 +3615,14 @@
           <a:lstStyle/>
           <a:p>
             <a:pPr>
-              <a:defRPr b="1" sz="2800">
-                <a:solidFill>
-                  <a:srgbClr val="1F1F1F"/>
+              <a:defRPr b="1" sz="2400">
+                <a:solidFill>
+                  <a:srgbClr val="0F172A"/>
                 </a:solidFill>
               </a:defRPr>
             </a:pPr>
             <a:r>
-              <a:t>초격차 기술: CoT(Chain of Thought) 실시간 감시</a:t>
+              <a:t>PART 4. CISO 설득 논리 및 성공 시나리오</a:t>
             </a:r>
           </a:p>
         </p:txBody>
@@ -3570,7 +3636,7 @@
         <p:spPr>
           <a:xfrm>
             <a:off x="457200" y="1097280"/>
-            <a:ext cx="8229600" cy="457200"/>
+            <a:ext cx="8229600" cy="365760"/>
           </a:xfrm>
           <a:prstGeom prst="rect">
             <a:avLst/>
@@ -3584,14 +3650,14 @@
           <a:lstStyle/>
           <a:p>
             <a:pPr>
-              <a:defRPr sz="1800">
-                <a:solidFill>
-                  <a:srgbClr val="1F1F1F"/>
+              <a:defRPr b="1" sz="1600">
+                <a:solidFill>
+                  <a:srgbClr val="7B3CE9"/>
                 </a:solidFill>
               </a:defRPr>
             </a:pPr>
             <a:r>
-              <a:t>• Why: 단순 프롬프트 필터링(신분증 검사)은 '내부 행동'을 보장하지 못함</a:t>
+              <a:t>Key Messages</a:t>
             </a:r>
           </a:p>
         </p:txBody>
@@ -3613,33 +3679,173 @@
           <a:noFill/>
         </p:spPr>
         <p:txBody>
+          <a:bodyPr wrap="square">
+            <a:spAutoFit/>
+          </a:bodyPr>
+          <a:lstStyle/>
+          <a:p>
+            <a:pPr>
+              <a:defRPr sz="1300">
+                <a:solidFill>
+                  <a:srgbClr val="1F1F1F"/>
+                </a:solidFill>
+              </a:defRPr>
+            </a:pPr>
+            <a:r>
+              <a:t>• Accountability: 사고 책임 소재 명확화 및 법적 면책 근거 제공</a:t>
+            </a:r>
+          </a:p>
+        </p:txBody>
+      </p:sp>
+      <p:sp>
+        <p:nvSpPr>
+          <p:cNvPr id="6" name="TextBox 5"/>
+          <p:cNvSpPr txBox="1"/>
+          <p:nvPr/>
+        </p:nvSpPr>
+        <p:spPr>
+          <a:xfrm>
+            <a:off x="457200" y="1783080"/>
+            <a:ext cx="8229600" cy="457200"/>
+          </a:xfrm>
+          <a:prstGeom prst="rect">
+            <a:avLst/>
+          </a:prstGeom>
+          <a:noFill/>
+        </p:spPr>
+        <p:txBody>
+          <a:bodyPr wrap="square">
+            <a:spAutoFit/>
+          </a:bodyPr>
+          <a:lstStyle/>
+          <a:p>
+            <a:pPr>
+              <a:defRPr sz="1300">
+                <a:solidFill>
+                  <a:srgbClr val="1F1F1F"/>
+                </a:solidFill>
+              </a:defRPr>
+            </a:pPr>
+            <a:r>
+              <a:t>• Enabler: 혁신의 방해자가 아닌 '안전한 AX의 조력자'로의 포지셔닝</a:t>
+            </a:r>
+          </a:p>
+        </p:txBody>
+      </p:sp>
+      <p:sp>
+        <p:nvSpPr>
+          <p:cNvPr id="7" name="TextBox 6"/>
+          <p:cNvSpPr txBox="1"/>
+          <p:nvPr/>
+        </p:nvSpPr>
+        <p:spPr>
+          <a:xfrm>
+            <a:off x="457200" y="2103120"/>
+            <a:ext cx="8229600" cy="457200"/>
+          </a:xfrm>
+          <a:prstGeom prst="rect">
+            <a:avLst/>
+          </a:prstGeom>
+          <a:noFill/>
+        </p:spPr>
+        <p:txBody>
+          <a:bodyPr wrap="square">
+            <a:spAutoFit/>
+          </a:bodyPr>
+          <a:lstStyle/>
+          <a:p>
+            <a:pPr>
+              <a:defRPr sz="1300">
+                <a:solidFill>
+                  <a:srgbClr val="1F1F1F"/>
+                </a:solidFill>
+              </a:defRPr>
+            </a:pPr>
+            <a:r>
+              <a:t>• Asset Protection: 직접적 재무 손실(환각/오작동) 차단</a:t>
+            </a:r>
+          </a:p>
+        </p:txBody>
+      </p:sp>
+      <p:sp>
+        <p:nvSpPr>
+          <p:cNvPr id="8" name="TextBox 7"/>
+          <p:cNvSpPr txBox="1"/>
+          <p:nvPr/>
+        </p:nvSpPr>
+        <p:spPr>
+          <a:xfrm>
+            <a:off x="457200" y="2423160"/>
+            <a:ext cx="8229600" cy="365760"/>
+          </a:xfrm>
+          <a:prstGeom prst="rect">
+            <a:avLst/>
+          </a:prstGeom>
+          <a:noFill/>
+        </p:spPr>
+        <p:txBody>
           <a:bodyPr wrap="none">
             <a:spAutoFit/>
           </a:bodyPr>
           <a:lstStyle/>
           <a:p>
             <a:pPr>
-              <a:defRPr sz="1800">
+              <a:defRPr b="1" sz="1600">
+                <a:solidFill>
+                  <a:srgbClr val="7B3CE9"/>
+                </a:solidFill>
+              </a:defRPr>
+            </a:pPr>
+            <a:r>
+              <a:t>신한은행 '평화로운 하루' 시나리오</a:t>
+            </a:r>
+          </a:p>
+        </p:txBody>
+      </p:sp>
+      <p:sp>
+        <p:nvSpPr>
+          <p:cNvPr id="9" name="TextBox 8"/>
+          <p:cNvSpPr txBox="1"/>
+          <p:nvPr/>
+        </p:nvSpPr>
+        <p:spPr>
+          <a:xfrm>
+            <a:off x="457200" y="2788920"/>
+            <a:ext cx="8229600" cy="457200"/>
+          </a:xfrm>
+          <a:prstGeom prst="rect">
+            <a:avLst/>
+          </a:prstGeom>
+          <a:noFill/>
+        </p:spPr>
+        <p:txBody>
+          <a:bodyPr wrap="square">
+            <a:spAutoFit/>
+          </a:bodyPr>
+          <a:lstStyle/>
+          <a:p>
+            <a:pPr>
+              <a:defRPr sz="1300">
                 <a:solidFill>
                   <a:srgbClr val="1F1F1F"/>
                 </a:solidFill>
               </a:defRPr>
             </a:pPr>
             <a:r>
-              <a:t>• Case 1: 정상 요청 속에 숨겨진 '악의적 지시(Indirect Injection)' 탐지</a:t>
-            </a:r>
-          </a:p>
-        </p:txBody>
-      </p:sp>
-      <p:sp>
-        <p:nvSpPr>
-          <p:cNvPr id="6" name="TextBox 5"/>
+              <a:t>• 오전: AI-SPM이 API Key 노출 탐지 및 즉시 격리</a:t>
+            </a:r>
+          </a:p>
+        </p:txBody>
+      </p:sp>
+      <p:sp>
+        <p:nvSpPr>
+          <p:cNvPr id="10" name="TextBox 9"/>
           <p:cNvSpPr txBox="1"/>
           <p:nvPr/>
         </p:nvSpPr>
         <p:spPr>
           <a:xfrm>
-            <a:off x="457200" y="1828800"/>
+            <a:off x="457200" y="3108960"/>
             <a:ext cx="8229600" cy="457200"/>
           </a:xfrm>
           <a:prstGeom prst="rect">
@@ -3648,33 +3854,33 @@
           <a:noFill/>
         </p:spPr>
         <p:txBody>
-          <a:bodyPr wrap="none">
+          <a:bodyPr wrap="square">
             <a:spAutoFit/>
           </a:bodyPr>
           <a:lstStyle/>
           <a:p>
             <a:pPr>
-              <a:defRPr sz="1800">
+              <a:defRPr sz="1300">
                 <a:solidFill>
                   <a:srgbClr val="1F1F1F"/>
                 </a:solidFill>
               </a:defRPr>
             </a:pPr>
             <a:r>
-              <a:t>• Case 2: AI의 논리적 비약 및 환각에 의한 '규정 위반 결정' 선제 차단</a:t>
-            </a:r>
-          </a:p>
-        </p:txBody>
-      </p:sp>
-      <p:sp>
-        <p:nvSpPr>
-          <p:cNvPr id="7" name="TextBox 6"/>
+              <a:t>• 오후: Agent-SPM이 에이전트의 투자 성향 조작 의도 포착 및 차단</a:t>
+            </a:r>
+          </a:p>
+        </p:txBody>
+      </p:sp>
+      <p:sp>
+        <p:nvSpPr>
+          <p:cNvPr id="11" name="TextBox 10"/>
           <p:cNvSpPr txBox="1"/>
           <p:nvPr/>
         </p:nvSpPr>
         <p:spPr>
           <a:xfrm>
-            <a:off x="457200" y="2194560"/>
+            <a:off x="457200" y="3429000"/>
             <a:ext cx="8229600" cy="457200"/>
           </a:xfrm>
           <a:prstGeom prst="rect">
@@ -3683,55 +3889,20 @@
           <a:noFill/>
         </p:spPr>
         <p:txBody>
-          <a:bodyPr wrap="none">
+          <a:bodyPr wrap="square">
             <a:spAutoFit/>
           </a:bodyPr>
           <a:lstStyle/>
           <a:p>
             <a:pPr>
-              <a:defRPr sz="1800">
+              <a:defRPr sz="1300">
                 <a:solidFill>
                   <a:srgbClr val="1F1F1F"/>
                 </a:solidFill>
               </a:defRPr>
             </a:pPr>
             <a:r>
-              <a:t>• Mechanism: 사고 노출 -&gt; 토큰 인터셉트 -&gt; Shadow Reasoning 검증</a:t>
-            </a:r>
-          </a:p>
-        </p:txBody>
-      </p:sp>
-      <p:sp>
-        <p:nvSpPr>
-          <p:cNvPr id="8" name="TextBox 7"/>
-          <p:cNvSpPr txBox="1"/>
-          <p:nvPr/>
-        </p:nvSpPr>
-        <p:spPr>
-          <a:xfrm>
-            <a:off x="457200" y="2560320"/>
-            <a:ext cx="8229600" cy="457200"/>
-          </a:xfrm>
-          <a:prstGeom prst="rect">
-            <a:avLst/>
-          </a:prstGeom>
-          <a:noFill/>
-        </p:spPr>
-        <p:txBody>
-          <a:bodyPr wrap="none">
-            <a:spAutoFit/>
-          </a:bodyPr>
-          <a:lstStyle/>
-          <a:p>
-            <a:pPr>
-              <a:defRPr sz="1800">
-                <a:solidFill>
-                  <a:srgbClr val="1F1F1F"/>
-                </a:solidFill>
-              </a:defRPr>
-            </a:pPr>
-            <a:r>
-              <a:t>• Result: 우회 불가능한 '증명 가능한 지능(Provable Intelligence)' 구현</a:t>
+              <a:t>• 마감: 금감원 제출용 50페이지 실사 리포트 자동 생성 및 정시 퇴근</a:t>
             </a:r>
           </a:p>
         </p:txBody>
@@ -3828,14 +3999,14 @@
           <a:lstStyle/>
           <a:p>
             <a:pPr>
-              <a:defRPr b="1" sz="2800">
-                <a:solidFill>
-                  <a:srgbClr val="1F1F1F"/>
+              <a:defRPr b="1" sz="2400">
+                <a:solidFill>
+                  <a:srgbClr val="0F172A"/>
                 </a:solidFill>
               </a:defRPr>
             </a:pPr>
             <a:r>
-              <a:t>보안과 성능의 균형: 레이턴시 최적화 전략</a:t>
+              <a:t>서비스 진화 로드맵 요약</a:t>
             </a:r>
           </a:p>
         </p:txBody>
@@ -3857,338 +4028,332 @@
           <a:noFill/>
         </p:spPr>
         <p:txBody>
-          <a:bodyPr wrap="none">
+          <a:bodyPr wrap="square">
             <a:spAutoFit/>
           </a:bodyPr>
           <a:lstStyle/>
           <a:p>
             <a:pPr>
-              <a:defRPr sz="1800">
+              <a:defRPr sz="1300">
                 <a:solidFill>
                   <a:srgbClr val="1F1F1F"/>
                 </a:solidFill>
               </a:defRPr>
             </a:pPr>
             <a:r>
-              <a:t>• Async Streaming: 생성과 동시에 보안 분석을 수행하여 대기 시간 최소화</a:t>
-            </a:r>
-          </a:p>
-        </p:txBody>
-      </p:sp>
-      <p:sp>
-        <p:nvSpPr>
-          <p:cNvPr id="5" name="TextBox 4"/>
-          <p:cNvSpPr txBox="1"/>
-          <p:nvPr/>
-        </p:nvSpPr>
-        <p:spPr>
-          <a:xfrm>
-            <a:off x="457200" y="1463040"/>
-            <a:ext cx="8229600" cy="457200"/>
-          </a:xfrm>
-          <a:prstGeom prst="rect">
-            <a:avLst/>
-          </a:prstGeom>
-          <a:noFill/>
-        </p:spPr>
-        <p:txBody>
-          <a:bodyPr wrap="none">
-            <a:spAutoFit/>
-          </a:bodyPr>
-          <a:lstStyle/>
-          <a:p>
-            <a:pPr>
-              <a:defRPr sz="1800">
-                <a:solidFill>
-                  <a:srgbClr val="1F1F1F"/>
-                </a:solidFill>
-              </a:defRPr>
-            </a:pPr>
-            <a:r>
-              <a:t>• Lightweight Agents: 2B 이하의 초경량 보안 모델을 통한 연산 부하 5% 미만 억제</a:t>
-            </a:r>
-          </a:p>
-        </p:txBody>
-      </p:sp>
-      <p:sp>
-        <p:nvSpPr>
-          <p:cNvPr id="6" name="TextBox 5"/>
-          <p:cNvSpPr txBox="1"/>
-          <p:nvPr/>
-        </p:nvSpPr>
-        <p:spPr>
-          <a:xfrm>
-            <a:off x="457200" y="1828800"/>
-            <a:ext cx="8229600" cy="457200"/>
-          </a:xfrm>
-          <a:prstGeom prst="rect">
-            <a:avLst/>
-          </a:prstGeom>
-          <a:noFill/>
-        </p:spPr>
-        <p:txBody>
-          <a:bodyPr wrap="none">
-            <a:spAutoFit/>
-          </a:bodyPr>
-          <a:lstStyle/>
-          <a:p>
-            <a:pPr>
-              <a:defRPr sz="1800">
-                <a:solidFill>
-                  <a:srgbClr val="1F1F1F"/>
-                </a:solidFill>
-              </a:defRPr>
-            </a:pPr>
-            <a:r>
-              <a:t>• Parallel Pipeline: 데이터 조회, 정제, 분석 과정을 병렬로 처리</a:t>
-            </a:r>
-          </a:p>
-        </p:txBody>
-      </p:sp>
-      <p:sp>
-        <p:nvSpPr>
-          <p:cNvPr id="7" name="TextBox 6"/>
-          <p:cNvSpPr txBox="1"/>
-          <p:nvPr/>
-        </p:nvSpPr>
-        <p:spPr>
-          <a:xfrm>
-            <a:off x="457200" y="2194560"/>
-            <a:ext cx="8229600" cy="457200"/>
-          </a:xfrm>
-          <a:prstGeom prst="rect">
-            <a:avLst/>
-          </a:prstGeom>
-          <a:noFill/>
-        </p:spPr>
-        <p:txBody>
-          <a:bodyPr wrap="none">
-            <a:spAutoFit/>
-          </a:bodyPr>
-          <a:lstStyle/>
-          <a:p>
-            <a:pPr>
-              <a:defRPr sz="1800">
-                <a:solidFill>
-                  <a:srgbClr val="1F1F1F"/>
-                </a:solidFill>
-              </a:defRPr>
-            </a:pPr>
-            <a:r>
-              <a:t>• Result: 강력한 3중 보안에도 불구하고 기존 대비 95% 이상의 성능 유지</a:t>
-            </a:r>
-          </a:p>
-        </p:txBody>
-      </p:sp>
-    </p:spTree>
-  </p:cSld>
-  <p:clrMapOvr>
-    <a:masterClrMapping/>
-  </p:clrMapOvr>
-</p:sld>
-</file>
-
-<file path=ppt/slides/slide13.xml><?xml version="1.0" encoding="utf-8"?>
-<p:sld xmlns:a="http://schemas.openxmlformats.org/drawingml/2006/main" xmlns:p="http://schemas.openxmlformats.org/presentationml/2006/main" xmlns:r="http://schemas.openxmlformats.org/officeDocument/2006/relationships">
-  <p:cSld>
-    <p:bg>
-      <p:bgPr>
-        <a:solidFill>
-          <a:srgbClr val="FFFFFF"/>
-        </a:solidFill>
-        <a:effectLst/>
-      </p:bgPr>
-    </p:bg>
-    <p:spTree>
-      <p:nvGrpSpPr>
-        <p:cNvPr id="1" name=""/>
-        <p:cNvGrpSpPr/>
-        <p:nvPr/>
-      </p:nvGrpSpPr>
-      <p:grpSpPr/>
-      <p:sp>
-        <p:nvSpPr>
-          <p:cNvPr id="2" name="Rectangle 1"/>
-          <p:cNvSpPr/>
-          <p:nvPr/>
-        </p:nvSpPr>
-        <p:spPr>
-          <a:xfrm>
-            <a:off x="457200" y="365760"/>
-            <a:ext cx="91440" cy="457200"/>
-          </a:xfrm>
-          <a:prstGeom prst="rect">
-            <a:avLst/>
-          </a:prstGeom>
-          <a:solidFill>
-            <a:srgbClr val="7B3CE9"/>
-          </a:solidFill>
-          <a:ln>
-            <a:noFill/>
-          </a:ln>
-        </p:spPr>
-        <p:style>
-          <a:lnRef idx="1">
-            <a:schemeClr val="accent1"/>
-          </a:lnRef>
-          <a:fillRef idx="3">
-            <a:schemeClr val="accent1"/>
-          </a:fillRef>
-          <a:effectRef idx="2">
-            <a:schemeClr val="accent1"/>
-          </a:effectRef>
-          <a:fontRef idx="minor">
-            <a:schemeClr val="lt1"/>
-          </a:fontRef>
-        </p:style>
-        <p:txBody>
-          <a:bodyPr rtlCol="0" anchor="ctr"/>
-          <a:lstStyle/>
-          <a:p>
-            <a:pPr algn="ctr"/>
-          </a:p>
-        </p:txBody>
-      </p:sp>
-      <p:sp>
-        <p:nvSpPr>
-          <p:cNvPr id="3" name="TextBox 2"/>
-          <p:cNvSpPr txBox="1"/>
-          <p:nvPr/>
-        </p:nvSpPr>
-        <p:spPr>
-          <a:xfrm>
-            <a:off x="640080" y="274320"/>
-            <a:ext cx="7315200" cy="640080"/>
-          </a:xfrm>
-          <a:prstGeom prst="rect">
-            <a:avLst/>
-          </a:prstGeom>
-          <a:noFill/>
-        </p:spPr>
-        <p:txBody>
-          <a:bodyPr wrap="none">
-            <a:spAutoFit/>
-          </a:bodyPr>
-          <a:lstStyle/>
-          <a:p>
-            <a:pPr>
-              <a:defRPr b="1" sz="2800">
-                <a:solidFill>
-                  <a:srgbClr val="1F1F1F"/>
-                </a:solidFill>
-              </a:defRPr>
-            </a:pPr>
-            <a:r>
-              <a:t>Closing: AX 전환의 신뢰 가드레일</a:t>
-            </a:r>
-          </a:p>
-        </p:txBody>
-      </p:sp>
-      <p:sp>
-        <p:nvSpPr>
-          <p:cNvPr id="4" name="TextBox 3"/>
-          <p:cNvSpPr txBox="1"/>
-          <p:nvPr/>
-        </p:nvSpPr>
-        <p:spPr>
-          <a:xfrm>
-            <a:off x="457200" y="1097280"/>
-            <a:ext cx="8229600" cy="457200"/>
-          </a:xfrm>
-          <a:prstGeom prst="rect">
-            <a:avLst/>
-          </a:prstGeom>
-          <a:noFill/>
-        </p:spPr>
-        <p:txBody>
-          <a:bodyPr wrap="none">
-            <a:spAutoFit/>
-          </a:bodyPr>
-          <a:lstStyle/>
-          <a:p>
-            <a:pPr>
-              <a:defRPr sz="1800">
-                <a:solidFill>
-                  <a:srgbClr val="1F1F1F"/>
-                </a:solidFill>
-              </a:defRPr>
-            </a:pPr>
-            <a:r>
-              <a:t>• 보안은 혁신의 걸림돌이 아니라, 혁신의 속도를 높여주는 브레이크</a:t>
-            </a:r>
-          </a:p>
-        </p:txBody>
-      </p:sp>
-      <p:sp>
-        <p:nvSpPr>
-          <p:cNvPr id="5" name="TextBox 4"/>
-          <p:cNvSpPr txBox="1"/>
-          <p:nvPr/>
-        </p:nvSpPr>
-        <p:spPr>
-          <a:xfrm>
-            <a:off x="457200" y="1463040"/>
-            <a:ext cx="8229600" cy="457200"/>
-          </a:xfrm>
-          <a:prstGeom prst="rect">
-            <a:avLst/>
-          </a:prstGeom>
-          <a:noFill/>
-        </p:spPr>
-        <p:txBody>
-          <a:bodyPr wrap="none">
-            <a:spAutoFit/>
-          </a:bodyPr>
-          <a:lstStyle/>
-          <a:p>
-            <a:pPr>
-              <a:defRPr sz="1800">
-                <a:solidFill>
-                  <a:srgbClr val="1F1F1F"/>
-                </a:solidFill>
-              </a:defRPr>
-            </a:pPr>
-            <a:r>
-              <a:t>• Safe AI는 기업이 마음 놓고 AI를 현업에 투입하게 만드는 마지막 퍼즐</a:t>
-            </a:r>
-          </a:p>
-        </p:txBody>
-      </p:sp>
-      <p:sp>
-        <p:nvSpPr>
-          <p:cNvPr id="6" name="TextBox 5"/>
-          <p:cNvSpPr txBox="1"/>
-          <p:nvPr/>
-        </p:nvSpPr>
-        <p:spPr>
-          <a:xfrm>
-            <a:off x="457200" y="1828800"/>
-            <a:ext cx="8229600" cy="457200"/>
-          </a:xfrm>
-          <a:prstGeom prst="rect">
-            <a:avLst/>
-          </a:prstGeom>
-          <a:noFill/>
-        </p:spPr>
-        <p:txBody>
-          <a:bodyPr wrap="none">
-            <a:spAutoFit/>
-          </a:bodyPr>
-          <a:lstStyle/>
-          <a:p>
-            <a:pPr>
-              <a:defRPr sz="1800">
-                <a:solidFill>
-                  <a:srgbClr val="1F1F1F"/>
-                </a:solidFill>
-              </a:defRPr>
-            </a:pPr>
-            <a:r>
-              <a:t>• U+ Safe AI: 가장 안전한 기업용 AI 업무 환경의 표준이 되겠습니다.</a:t>
-            </a:r>
-          </a:p>
-        </p:txBody>
-      </p:sp>
+              <a:t>• 단기적으로 규제 대응(망분리) '미끼 상품'으로 진입하여, 중기적 초격차 기술(SPM)로 해자를 구축하고, 장기적 금융 생태계(보험/파기)로 수익 극대화</a:t>
+            </a:r>
+          </a:p>
+        </p:txBody>
+      </p:sp>
+      <p:graphicFrame>
+        <p:nvGraphicFramePr>
+          <p:cNvPr id="5" name="Table 4"/>
+          <p:cNvGraphicFramePr>
+            <a:graphicFrameLocks noGrp="1"/>
+          </p:cNvGraphicFramePr>
+          <p:nvPr/>
+        </p:nvGraphicFramePr>
+        <p:xfrm>
+          <a:off x="457200" y="1.7499999999999998"/>
+          <a:ext cx="8229600" cy="1097280"/>
+        </p:xfrm>
+        <a:graphic>
+          <a:graphicData uri="http://schemas.openxmlformats.org/drawingml/2006/table">
+            <a:tbl>
+              <a:tblPr firstRow="1" bandRow="1">
+                <a:tableStyleId>{5C22544A-7EE6-4342-B048-85BDC9FD1C3A}</a:tableStyleId>
+              </a:tblPr>
+              <a:tblGrid>
+                <a:gridCol w="2057400"/>
+                <a:gridCol w="2057400"/>
+                <a:gridCol w="2057400"/>
+                <a:gridCol w="2057400"/>
+              </a:tblGrid>
+              <a:tr h="274320">
+                <a:tc>
+                  <a:txBody>
+                    <a:bodyPr/>
+                    <a:lstStyle/>
+                    <a:p>
+                      <a:pPr>
+                        <a:defRPr sz="1000" b="1">
+                          <a:solidFill>
+                            <a:srgbClr val="FFFFFF"/>
+                          </a:solidFill>
+                        </a:defRPr>
+                      </a:pPr>
+                      <a:r>
+                        <a:t>단계</a:t>
+                      </a:r>
+                    </a:p>
+                  </a:txBody>
+                  <a:tcPr>
+                    <a:solidFill>
+                      <a:srgbClr val="7B3CE9"/>
+                    </a:solidFill>
+                  </a:tcPr>
+                </a:tc>
+                <a:tc>
+                  <a:txBody>
+                    <a:bodyPr/>
+                    <a:lstStyle/>
+                    <a:p>
+                      <a:pPr>
+                        <a:defRPr sz="1000" b="1">
+                          <a:solidFill>
+                            <a:srgbClr val="FFFFFF"/>
+                          </a:solidFill>
+                        </a:defRPr>
+                      </a:pPr>
+                      <a:r>
+                        <a:t>핵심 타겟</a:t>
+                      </a:r>
+                    </a:p>
+                  </a:txBody>
+                  <a:tcPr>
+                    <a:solidFill>
+                      <a:srgbClr val="7B3CE9"/>
+                    </a:solidFill>
+                  </a:tcPr>
+                </a:tc>
+                <a:tc>
+                  <a:txBody>
+                    <a:bodyPr/>
+                    <a:lstStyle/>
+                    <a:p>
+                      <a:pPr>
+                        <a:defRPr sz="1000" b="1">
+                          <a:solidFill>
+                            <a:srgbClr val="FFFFFF"/>
+                          </a:solidFill>
+                        </a:defRPr>
+                      </a:pPr>
+                      <a:r>
+                        <a:t>수요(Urgency)</a:t>
+                      </a:r>
+                    </a:p>
+                  </a:txBody>
+                  <a:tcPr>
+                    <a:solidFill>
+                      <a:srgbClr val="7B3CE9"/>
+                    </a:solidFill>
+                  </a:tcPr>
+                </a:tc>
+                <a:tc>
+                  <a:txBody>
+                    <a:bodyPr/>
+                    <a:lstStyle/>
+                    <a:p>
+                      <a:pPr>
+                        <a:defRPr sz="1000" b="1">
+                          <a:solidFill>
+                            <a:srgbClr val="FFFFFF"/>
+                          </a:solidFill>
+                        </a:defRPr>
+                      </a:pPr>
+                      <a:r>
+                        <a:t>수익성(Profit)</a:t>
+                      </a:r>
+                    </a:p>
+                  </a:txBody>
+                  <a:tcPr>
+                    <a:solidFill>
+                      <a:srgbClr val="7B3CE9"/>
+                    </a:solidFill>
+                  </a:tcPr>
+                </a:tc>
+              </a:tr>
+              <a:tr h="274320">
+                <a:tc>
+                  <a:txBody>
+                    <a:bodyPr/>
+                    <a:lstStyle/>
+                    <a:p>
+                      <a:pPr>
+                        <a:defRPr sz="1000"/>
+                      </a:pPr>
+                      <a:r>
+                        <a:t>Phase 1 (단기)</a:t>
+                      </a:r>
+                    </a:p>
+                  </a:txBody>
+                  <a:tcPr/>
+                </a:tc>
+                <a:tc>
+                  <a:txBody>
+                    <a:bodyPr/>
+                    <a:lstStyle/>
+                    <a:p>
+                      <a:pPr>
+                        <a:defRPr sz="1000"/>
+                      </a:pPr>
+                      <a:r>
+                        <a:t>망분리 대응 금융권</a:t>
+                      </a:r>
+                    </a:p>
+                  </a:txBody>
+                  <a:tcPr/>
+                </a:tc>
+                <a:tc>
+                  <a:txBody>
+                    <a:bodyPr/>
+                    <a:lstStyle/>
+                    <a:p>
+                      <a:pPr>
+                        <a:defRPr sz="1000"/>
+                      </a:pPr>
+                      <a:r>
+                        <a:t>최상 (필수)</a:t>
+                      </a:r>
+                    </a:p>
+                  </a:txBody>
+                  <a:tcPr/>
+                </a:tc>
+                <a:tc>
+                  <a:txBody>
+                    <a:bodyPr/>
+                    <a:lstStyle/>
+                    <a:p>
+                      <a:pPr>
+                        <a:defRPr sz="1000"/>
+                      </a:pPr>
+                      <a:r>
+                        <a:t>중간</a:t>
+                      </a:r>
+                    </a:p>
+                  </a:txBody>
+                  <a:tcPr/>
+                </a:tc>
+              </a:tr>
+              <a:tr h="274320">
+                <a:tc>
+                  <a:txBody>
+                    <a:bodyPr/>
+                    <a:lstStyle/>
+                    <a:p>
+                      <a:pPr>
+                        <a:defRPr sz="1000"/>
+                      </a:pPr>
+                      <a:r>
+                        <a:t>Phase 2 (중기)</a:t>
+                      </a:r>
+                    </a:p>
+                  </a:txBody>
+                  <a:tcPr/>
+                </a:tc>
+                <a:tc>
+                  <a:txBody>
+                    <a:bodyPr/>
+                    <a:lstStyle/>
+                    <a:p>
+                      <a:pPr>
+                        <a:defRPr sz="1000"/>
+                      </a:pPr>
+                      <a:r>
+                        <a:t>AX 전면 도입 대기업</a:t>
+                      </a:r>
+                    </a:p>
+                  </a:txBody>
+                  <a:tcPr/>
+                </a:tc>
+                <a:tc>
+                  <a:txBody>
+                    <a:bodyPr/>
+                    <a:lstStyle/>
+                    <a:p>
+                      <a:pPr>
+                        <a:defRPr sz="1000"/>
+                      </a:pPr>
+                      <a:r>
+                        <a:t>높음 (A2A 리스크)</a:t>
+                      </a:r>
+                    </a:p>
+                  </a:txBody>
+                  <a:tcPr/>
+                </a:tc>
+                <a:tc>
+                  <a:txBody>
+                    <a:bodyPr/>
+                    <a:lstStyle/>
+                    <a:p>
+                      <a:pPr>
+                        <a:defRPr sz="1000"/>
+                      </a:pPr>
+                      <a:r>
+                        <a:t>상 (기술 프리미엄)</a:t>
+                      </a:r>
+                    </a:p>
+                  </a:txBody>
+                  <a:tcPr/>
+                </a:tc>
+              </a:tr>
+              <a:tr h="274320">
+                <a:tc>
+                  <a:txBody>
+                    <a:bodyPr/>
+                    <a:lstStyle/>
+                    <a:p>
+                      <a:pPr>
+                        <a:defRPr sz="1000"/>
+                      </a:pPr>
+                      <a:r>
+                        <a:t>Phase 3 (장기)</a:t>
+                      </a:r>
+                    </a:p>
+                  </a:txBody>
+                  <a:tcPr/>
+                </a:tc>
+                <a:tc>
+                  <a:txBody>
+                    <a:bodyPr/>
+                    <a:lstStyle/>
+                    <a:p>
+                      <a:pPr>
+                        <a:defRPr sz="1000"/>
+                      </a:pPr>
+                      <a:r>
+                        <a:t>생태계 및 리스크 관리</a:t>
+                      </a:r>
+                    </a:p>
+                  </a:txBody>
+                  <a:tcPr/>
+                </a:tc>
+                <a:tc>
+                  <a:txBody>
+                    <a:bodyPr/>
+                    <a:lstStyle/>
+                    <a:p>
+                      <a:pPr>
+                        <a:defRPr sz="1000"/>
+                      </a:pPr>
+                      <a:r>
+                        <a:t>보통</a:t>
+                      </a:r>
+                    </a:p>
+                  </a:txBody>
+                  <a:tcPr/>
+                </a:tc>
+                <a:tc>
+                  <a:txBody>
+                    <a:bodyPr/>
+                    <a:lstStyle/>
+                    <a:p>
+                      <a:pPr>
+                        <a:defRPr sz="1000"/>
+                      </a:pPr>
+                      <a:r>
+                        <a:t>최상 (보험 연계)</a:t>
+                      </a:r>
+                    </a:p>
+                  </a:txBody>
+                  <a:tcPr/>
+                </a:tc>
+              </a:tr>
+            </a:tbl>
+          </a:graphicData>
+        </a:graphic>
+      </p:graphicFrame>
     </p:spTree>
   </p:cSld>
   <p:clrMapOvr>
@@ -4281,28 +4446,52 @@
           <a:lstStyle/>
           <a:p>
             <a:pPr>
-              <a:defRPr b="1" sz="2800">
-                <a:solidFill>
-                  <a:srgbClr val="1F1F1F"/>
+              <a:defRPr b="1" sz="2400">
+                <a:solidFill>
+                  <a:srgbClr val="0F172A"/>
                 </a:solidFill>
               </a:defRPr>
             </a:pPr>
             <a:r>
-              <a:t>시장 상황: Gateway 레드오션과 신규 기회</a:t>
-            </a:r>
-          </a:p>
-        </p:txBody>
-      </p:sp>
-      <p:sp>
-        <p:nvSpPr>
-          <p:cNvPr id="4" name="TextBox 3"/>
+              <a:t>PART 1. 개요 및 전략적 배경</a:t>
+            </a:r>
+          </a:p>
+        </p:txBody>
+      </p:sp>
+      <p:pic>
+        <p:nvPicPr>
+          <p:cNvPr id="4" name="Picture 3" descr="ai_security_dashboard_futuristic_1778200297333.png"/>
+          <p:cNvPicPr>
+            <a:picLocks noChangeAspect="1"/>
+          </p:cNvPicPr>
+          <p:nvPr/>
+        </p:nvPicPr>
+        <p:blipFill>
+          <a:blip r:embed="rId2"/>
+          <a:stretch>
+            <a:fillRect/>
+          </a:stretch>
+        </p:blipFill>
+        <p:spPr>
+          <a:xfrm>
+            <a:off x="4754880" y="1371600"/>
+            <a:ext cx="3931920" cy="3931920"/>
+          </a:xfrm>
+          <a:prstGeom prst="rect">
+            <a:avLst/>
+          </a:prstGeom>
+        </p:spPr>
+      </p:pic>
+      <p:sp>
+        <p:nvSpPr>
+          <p:cNvPr id="5" name="TextBox 4"/>
           <p:cNvSpPr txBox="1"/>
           <p:nvPr/>
         </p:nvSpPr>
         <p:spPr>
           <a:xfrm>
             <a:off x="457200" y="1097280"/>
-            <a:ext cx="8229600" cy="457200"/>
+            <a:ext cx="4114800" cy="365760"/>
           </a:xfrm>
           <a:prstGeom prst="rect">
             <a:avLst/>
@@ -4316,28 +4505,133 @@
           <a:lstStyle/>
           <a:p>
             <a:pPr>
-              <a:defRPr sz="1800">
+              <a:defRPr b="1" sz="1600">
+                <a:solidFill>
+                  <a:srgbClr val="7B3CE9"/>
+                </a:solidFill>
+              </a:defRPr>
+            </a:pPr>
+            <a:r>
+              <a:t>전략적 개요</a:t>
+            </a:r>
+          </a:p>
+        </p:txBody>
+      </p:sp>
+      <p:sp>
+        <p:nvSpPr>
+          <p:cNvPr id="6" name="TextBox 5"/>
+          <p:cNvSpPr txBox="1"/>
+          <p:nvPr/>
+        </p:nvSpPr>
+        <p:spPr>
+          <a:xfrm>
+            <a:off x="457200" y="1463040"/>
+            <a:ext cx="4114800" cy="457200"/>
+          </a:xfrm>
+          <a:prstGeom prst="rect">
+            <a:avLst/>
+          </a:prstGeom>
+          <a:noFill/>
+        </p:spPr>
+        <p:txBody>
+          <a:bodyPr wrap="square">
+            <a:spAutoFit/>
+          </a:bodyPr>
+          <a:lstStyle/>
+          <a:p>
+            <a:pPr>
+              <a:defRPr sz="1300">
                 <a:solidFill>
                   <a:srgbClr val="1F1F1F"/>
                 </a:solidFill>
               </a:defRPr>
             </a:pPr>
             <a:r>
-              <a:t>• AI Gateway 시장 포화: 단순 트래픽 제어는 이미 Commodity화</a:t>
-            </a:r>
-          </a:p>
-        </p:txBody>
-      </p:sp>
-      <p:sp>
-        <p:nvSpPr>
-          <p:cNvPr id="5" name="TextBox 4"/>
+              <a:t>• 단순한 'AI 입구 보안(Gateway)'을 넘어선 'Full-Stack AI Governance' 구축</a:t>
+            </a:r>
+          </a:p>
+        </p:txBody>
+      </p:sp>
+      <p:sp>
+        <p:nvSpPr>
+          <p:cNvPr id="7" name="TextBox 6"/>
           <p:cNvSpPr txBox="1"/>
           <p:nvPr/>
         </p:nvSpPr>
         <p:spPr>
           <a:xfrm>
-            <a:off x="457200" y="1463040"/>
-            <a:ext cx="8229600" cy="457200"/>
+            <a:off x="457200" y="1783080"/>
+            <a:ext cx="4114800" cy="457200"/>
+          </a:xfrm>
+          <a:prstGeom prst="rect">
+            <a:avLst/>
+          </a:prstGeom>
+          <a:noFill/>
+        </p:spPr>
+        <p:txBody>
+          <a:bodyPr wrap="square">
+            <a:spAutoFit/>
+          </a:bodyPr>
+          <a:lstStyle/>
+          <a:p>
+            <a:pPr>
+              <a:defRPr sz="1300">
+                <a:solidFill>
+                  <a:srgbClr val="1F1F1F"/>
+                </a:solidFill>
+              </a:defRPr>
+            </a:pPr>
+            <a:r>
+              <a:t>• AI 모델의 생성-운영-폐기(Lifecycle) 전 과정에서의 데이터 안전성 및 추론 무결성 보장</a:t>
+            </a:r>
+          </a:p>
+        </p:txBody>
+      </p:sp>
+      <p:sp>
+        <p:nvSpPr>
+          <p:cNvPr id="8" name="TextBox 7"/>
+          <p:cNvSpPr txBox="1"/>
+          <p:nvPr/>
+        </p:nvSpPr>
+        <p:spPr>
+          <a:xfrm>
+            <a:off x="457200" y="2103120"/>
+            <a:ext cx="4114800" cy="457200"/>
+          </a:xfrm>
+          <a:prstGeom prst="rect">
+            <a:avLst/>
+          </a:prstGeom>
+          <a:noFill/>
+        </p:spPr>
+        <p:txBody>
+          <a:bodyPr wrap="square">
+            <a:spAutoFit/>
+          </a:bodyPr>
+          <a:lstStyle/>
+          <a:p>
+            <a:pPr>
+              <a:defRPr sz="1300">
+                <a:solidFill>
+                  <a:srgbClr val="1F1F1F"/>
+                </a:solidFill>
+              </a:defRPr>
+            </a:pPr>
+            <a:r>
+              <a:t>• 2026년 에이전틱 AI(Agentic AI) 시대의 핵심 보안 인프라</a:t>
+            </a:r>
+          </a:p>
+        </p:txBody>
+      </p:sp>
+      <p:sp>
+        <p:nvSpPr>
+          <p:cNvPr id="9" name="TextBox 8"/>
+          <p:cNvSpPr txBox="1"/>
+          <p:nvPr/>
+        </p:nvSpPr>
+        <p:spPr>
+          <a:xfrm>
+            <a:off x="457200" y="2423160"/>
+            <a:ext cx="4114800" cy="365760"/>
           </a:xfrm>
           <a:prstGeom prst="rect">
             <a:avLst/>
@@ -4351,28 +4645,63 @@
           <a:lstStyle/>
           <a:p>
             <a:pPr>
-              <a:defRPr sz="1800">
+              <a:defRPr b="1" sz="1600">
+                <a:solidFill>
+                  <a:srgbClr val="7B3CE9"/>
+                </a:solidFill>
+              </a:defRPr>
+            </a:pPr>
+            <a:r>
+              <a:t>전략 목표 (Strategic Objectives)</a:t>
+            </a:r>
+          </a:p>
+        </p:txBody>
+      </p:sp>
+      <p:sp>
+        <p:nvSpPr>
+          <p:cNvPr id="10" name="TextBox 9"/>
+          <p:cNvSpPr txBox="1"/>
+          <p:nvPr/>
+        </p:nvSpPr>
+        <p:spPr>
+          <a:xfrm>
+            <a:off x="457200" y="2788920"/>
+            <a:ext cx="4114800" cy="457200"/>
+          </a:xfrm>
+          <a:prstGeom prst="rect">
+            <a:avLst/>
+          </a:prstGeom>
+          <a:noFill/>
+        </p:spPr>
+        <p:txBody>
+          <a:bodyPr wrap="square">
+            <a:spAutoFit/>
+          </a:bodyPr>
+          <a:lstStyle/>
+          <a:p>
+            <a:pPr>
+              <a:defRPr sz="1300">
                 <a:solidFill>
                   <a:srgbClr val="1F1F1F"/>
                 </a:solidFill>
               </a:defRPr>
             </a:pPr>
             <a:r>
-              <a:t>• Agentic Shift: 인간의 개입 없는 '자율형 에이전트' 도입 가속화</a:t>
-            </a:r>
-          </a:p>
-        </p:txBody>
-      </p:sp>
-      <p:sp>
-        <p:nvSpPr>
-          <p:cNvPr id="6" name="TextBox 5"/>
+              <a:t>• Visibility: 에이전트 사고 과정(CoT) 및 데이터 흐름의 완벽 가시성</a:t>
+            </a:r>
+          </a:p>
+        </p:txBody>
+      </p:sp>
+      <p:sp>
+        <p:nvSpPr>
+          <p:cNvPr id="11" name="TextBox 10"/>
           <p:cNvSpPr txBox="1"/>
           <p:nvPr/>
         </p:nvSpPr>
         <p:spPr>
           <a:xfrm>
-            <a:off x="457200" y="1828800"/>
-            <a:ext cx="8229600" cy="457200"/>
+            <a:off x="457200" y="3108960"/>
+            <a:ext cx="4114800" cy="457200"/>
           </a:xfrm>
           <a:prstGeom prst="rect">
             <a:avLst/>
@@ -4380,34 +4709,34 @@
           <a:noFill/>
         </p:spPr>
         <p:txBody>
-          <a:bodyPr wrap="none">
+          <a:bodyPr wrap="square">
             <a:spAutoFit/>
           </a:bodyPr>
           <a:lstStyle/>
           <a:p>
             <a:pPr>
-              <a:defRPr sz="1800">
+              <a:defRPr sz="1300">
                 <a:solidFill>
                   <a:srgbClr val="1F1F1F"/>
                 </a:solidFill>
               </a:defRPr>
             </a:pPr>
             <a:r>
-              <a:t>• 보안 패러다임의 변화:</a:t>
-            </a:r>
-          </a:p>
-        </p:txBody>
-      </p:sp>
-      <p:sp>
-        <p:nvSpPr>
-          <p:cNvPr id="7" name="TextBox 6"/>
+              <a:t>• Control: 자율형 AI 일탈 행위에 대한 실시간 'Kill-Switch'</a:t>
+            </a:r>
+          </a:p>
+        </p:txBody>
+      </p:sp>
+      <p:sp>
+        <p:nvSpPr>
+          <p:cNvPr id="12" name="TextBox 11"/>
           <p:cNvSpPr txBox="1"/>
           <p:nvPr/>
         </p:nvSpPr>
         <p:spPr>
           <a:xfrm>
-            <a:off x="731520" y="2194560"/>
-            <a:ext cx="7772400" cy="365760"/>
+            <a:off x="457200" y="3429000"/>
+            <a:ext cx="4114800" cy="457200"/>
           </a:xfrm>
           <a:prstGeom prst="rect">
             <a:avLst/>
@@ -4415,34 +4744,34 @@
           <a:noFill/>
         </p:spPr>
         <p:txBody>
-          <a:bodyPr wrap="none">
+          <a:bodyPr wrap="square">
             <a:spAutoFit/>
           </a:bodyPr>
           <a:lstStyle/>
           <a:p>
             <a:pPr>
-              <a:defRPr sz="1400">
-                <a:solidFill>
-                  <a:srgbClr val="666666"/>
+              <a:defRPr sz="1300">
+                <a:solidFill>
+                  <a:srgbClr val="1F1F1F"/>
                 </a:solidFill>
               </a:defRPr>
             </a:pPr>
             <a:r>
-              <a:t>  - Perimeter(입구) → Behavior(행위) 중심의 보안으로 이동</a:t>
-            </a:r>
-          </a:p>
-        </p:txBody>
-      </p:sp>
-      <p:sp>
-        <p:nvSpPr>
-          <p:cNvPr id="8" name="TextBox 7"/>
+              <a:t>• Trust: 증명 가능한 보안 이력을 통한 AI 서비스 수용성 제고</a:t>
+            </a:r>
+          </a:p>
+        </p:txBody>
+      </p:sp>
+      <p:sp>
+        <p:nvSpPr>
+          <p:cNvPr id="13" name="TextBox 12"/>
           <p:cNvSpPr txBox="1"/>
           <p:nvPr/>
         </p:nvSpPr>
         <p:spPr>
           <a:xfrm>
-            <a:off x="731520" y="2468879"/>
-            <a:ext cx="7772400" cy="365760"/>
+            <a:off x="457200" y="3749040"/>
+            <a:ext cx="4114800" cy="457200"/>
           </a:xfrm>
           <a:prstGeom prst="rect">
             <a:avLst/>
@@ -4450,20 +4779,20 @@
           <a:noFill/>
         </p:spPr>
         <p:txBody>
-          <a:bodyPr wrap="none">
+          <a:bodyPr wrap="square">
             <a:spAutoFit/>
           </a:bodyPr>
           <a:lstStyle/>
           <a:p>
             <a:pPr>
-              <a:defRPr sz="1400">
-                <a:solidFill>
-                  <a:srgbClr val="666666"/>
+              <a:defRPr sz="1300">
+                <a:solidFill>
+                  <a:srgbClr val="1F1F1F"/>
                 </a:solidFill>
               </a:defRPr>
             </a:pPr>
             <a:r>
-              <a:t>  - 정적 룰셋 → 실시간 문맥(Context) 분석 필요성 증대</a:t>
+              <a:t>• Efficiency: 규제 대응 자동화를 통한 보안 조직 운영 효율 극대화</a:t>
             </a:r>
           </a:p>
         </p:txBody>
@@ -4560,14 +4889,14 @@
           <a:lstStyle/>
           <a:p>
             <a:pPr>
-              <a:defRPr b="1" sz="2800">
-                <a:solidFill>
-                  <a:srgbClr val="1F1F1F"/>
+              <a:defRPr b="1" sz="2400">
+                <a:solidFill>
+                  <a:srgbClr val="0F172A"/>
                 </a:solidFill>
               </a:defRPr>
             </a:pPr>
             <a:r>
-              <a:t>전략 Pillar 1: AI-Native DSPM</a:t>
+              <a:t>글로벌 표준 부합성: Gartner AI TRiSM</a:t>
             </a:r>
           </a:p>
         </p:txBody>
@@ -4581,7 +4910,7 @@
         <p:spPr>
           <a:xfrm>
             <a:off x="457200" y="1097280"/>
-            <a:ext cx="8229600" cy="457200"/>
+            <a:ext cx="8229600" cy="365760"/>
           </a:xfrm>
           <a:prstGeom prst="rect">
             <a:avLst/>
@@ -4595,14 +4924,14 @@
           <a:lstStyle/>
           <a:p>
             <a:pPr>
-              <a:defRPr sz="1800">
-                <a:solidFill>
-                  <a:srgbClr val="1F1F1F"/>
+              <a:defRPr b="1" sz="1600">
+                <a:solidFill>
+                  <a:srgbClr val="7B3CE9"/>
                 </a:solidFill>
               </a:defRPr>
             </a:pPr>
             <a:r>
-              <a:t>• 벡터 DB 및 RAG 파이프라인 데이터 보안 형상 관리</a:t>
+              <a:t>AI TRiSM (Trust, Risk, and Security Management)</a:t>
             </a:r>
           </a:p>
         </p:txBody>
@@ -4624,125 +4953,195 @@
           <a:noFill/>
         </p:spPr>
         <p:txBody>
+          <a:bodyPr wrap="square">
+            <a:spAutoFit/>
+          </a:bodyPr>
+          <a:lstStyle/>
+          <a:p>
+            <a:pPr>
+              <a:defRPr sz="1300">
+                <a:solidFill>
+                  <a:srgbClr val="1F1F1F"/>
+                </a:solidFill>
+              </a:defRPr>
+            </a:pPr>
+            <a:r>
+              <a:t>• Gartner가 제시한 AI 거버넌스의 표준 프레임워크를 100% 구현</a:t>
+            </a:r>
+          </a:p>
+        </p:txBody>
+      </p:sp>
+      <p:sp>
+        <p:nvSpPr>
+          <p:cNvPr id="6" name="TextBox 5"/>
+          <p:cNvSpPr txBox="1"/>
+          <p:nvPr/>
+        </p:nvSpPr>
+        <p:spPr>
+          <a:xfrm>
+            <a:off x="457200" y="1783080"/>
+            <a:ext cx="8229600" cy="457200"/>
+          </a:xfrm>
+          <a:prstGeom prst="rect">
+            <a:avLst/>
+          </a:prstGeom>
+          <a:noFill/>
+        </p:spPr>
+        <p:txBody>
+          <a:bodyPr wrap="square">
+            <a:spAutoFit/>
+          </a:bodyPr>
+          <a:lstStyle/>
+          <a:p>
+            <a:pPr>
+              <a:defRPr sz="1300">
+                <a:solidFill>
+                  <a:srgbClr val="1F1F1F"/>
+                </a:solidFill>
+              </a:defRPr>
+            </a:pPr>
+            <a:r>
+              <a:t>• 1. Trust (신뢰성): 설명 가능하고 투명한 AI (CoT 감시, Compliance XAI)</a:t>
+            </a:r>
+          </a:p>
+        </p:txBody>
+      </p:sp>
+      <p:sp>
+        <p:nvSpPr>
+          <p:cNvPr id="7" name="TextBox 6"/>
+          <p:cNvSpPr txBox="1"/>
+          <p:nvPr/>
+        </p:nvSpPr>
+        <p:spPr>
+          <a:xfrm>
+            <a:off x="457200" y="2103120"/>
+            <a:ext cx="8229600" cy="457200"/>
+          </a:xfrm>
+          <a:prstGeom prst="rect">
+            <a:avLst/>
+          </a:prstGeom>
+          <a:noFill/>
+        </p:spPr>
+        <p:txBody>
+          <a:bodyPr wrap="square">
+            <a:spAutoFit/>
+          </a:bodyPr>
+          <a:lstStyle/>
+          <a:p>
+            <a:pPr>
+              <a:defRPr sz="1300">
+                <a:solidFill>
+                  <a:srgbClr val="1F1F1F"/>
+                </a:solidFill>
+              </a:defRPr>
+            </a:pPr>
+            <a:r>
+              <a:t>• 2. Risk (리스크): 데이터 유출 및 모델 환각 선제적 방어 (Semantic DLP, DSPM)</a:t>
+            </a:r>
+          </a:p>
+        </p:txBody>
+      </p:sp>
+      <p:sp>
+        <p:nvSpPr>
+          <p:cNvPr id="8" name="TextBox 7"/>
+          <p:cNvSpPr txBox="1"/>
+          <p:nvPr/>
+        </p:nvSpPr>
+        <p:spPr>
+          <a:xfrm>
+            <a:off x="457200" y="2423160"/>
+            <a:ext cx="8229600" cy="457200"/>
+          </a:xfrm>
+          <a:prstGeom prst="rect">
+            <a:avLst/>
+          </a:prstGeom>
+          <a:noFill/>
+        </p:spPr>
+        <p:txBody>
+          <a:bodyPr wrap="square">
+            <a:spAutoFit/>
+          </a:bodyPr>
+          <a:lstStyle/>
+          <a:p>
+            <a:pPr>
+              <a:defRPr sz="1300">
+                <a:solidFill>
+                  <a:srgbClr val="1F1F1F"/>
+                </a:solidFill>
+              </a:defRPr>
+            </a:pPr>
+            <a:r>
+              <a:t>• 3. Security (보안): 런타임 공격 및 데이터 오염 실시간 차단 (Agent-SPM, Anti-Poisoning)</a:t>
+            </a:r>
+          </a:p>
+        </p:txBody>
+      </p:sp>
+      <p:sp>
+        <p:nvSpPr>
+          <p:cNvPr id="9" name="TextBox 8"/>
+          <p:cNvSpPr txBox="1"/>
+          <p:nvPr/>
+        </p:nvSpPr>
+        <p:spPr>
+          <a:xfrm>
+            <a:off x="457200" y="2743200"/>
+            <a:ext cx="8229600" cy="365760"/>
+          </a:xfrm>
+          <a:prstGeom prst="rect">
+            <a:avLst/>
+          </a:prstGeom>
+          <a:noFill/>
+        </p:spPr>
+        <p:txBody>
           <a:bodyPr wrap="none">
             <a:spAutoFit/>
           </a:bodyPr>
           <a:lstStyle/>
           <a:p>
             <a:pPr>
-              <a:defRPr sz="1800">
+              <a:defRPr b="1" sz="1600">
+                <a:solidFill>
+                  <a:srgbClr val="7B3CE9"/>
+                </a:solidFill>
+              </a:defRPr>
+            </a:pPr>
+            <a:r>
+              <a:t>Strategic Alignment</a:t>
+            </a:r>
+          </a:p>
+        </p:txBody>
+      </p:sp>
+      <p:sp>
+        <p:nvSpPr>
+          <p:cNvPr id="10" name="TextBox 9"/>
+          <p:cNvSpPr txBox="1"/>
+          <p:nvPr/>
+        </p:nvSpPr>
+        <p:spPr>
+          <a:xfrm>
+            <a:off x="457200" y="3108960"/>
+            <a:ext cx="8229600" cy="457200"/>
+          </a:xfrm>
+          <a:prstGeom prst="rect">
+            <a:avLst/>
+          </a:prstGeom>
+          <a:noFill/>
+        </p:spPr>
+        <p:txBody>
+          <a:bodyPr wrap="square">
+            <a:spAutoFit/>
+          </a:bodyPr>
+          <a:lstStyle/>
+          <a:p>
+            <a:pPr>
+              <a:defRPr sz="1300">
                 <a:solidFill>
                   <a:srgbClr val="1F1F1F"/>
                 </a:solidFill>
               </a:defRPr>
             </a:pPr>
             <a:r>
-              <a:t>• 핵심 기능:</a:t>
-            </a:r>
-          </a:p>
-        </p:txBody>
-      </p:sp>
-      <p:sp>
-        <p:nvSpPr>
-          <p:cNvPr id="6" name="TextBox 5"/>
-          <p:cNvSpPr txBox="1"/>
-          <p:nvPr/>
-        </p:nvSpPr>
-        <p:spPr>
-          <a:xfrm>
-            <a:off x="731520" y="1828800"/>
-            <a:ext cx="7772400" cy="365760"/>
-          </a:xfrm>
-          <a:prstGeom prst="rect">
-            <a:avLst/>
-          </a:prstGeom>
-          <a:noFill/>
-        </p:spPr>
-        <p:txBody>
-          <a:bodyPr wrap="none">
-            <a:spAutoFit/>
-          </a:bodyPr>
-          <a:lstStyle/>
-          <a:p>
-            <a:pPr>
-              <a:defRPr sz="1400">
-                <a:solidFill>
-                  <a:srgbClr val="666666"/>
-                </a:solidFill>
-              </a:defRPr>
-            </a:pPr>
-            <a:r>
-              <a:t>  - 임베딩 데이터 내 민감 정보(PII) 의미적 스캔</a:t>
-            </a:r>
-          </a:p>
-        </p:txBody>
-      </p:sp>
-      <p:sp>
-        <p:nvSpPr>
-          <p:cNvPr id="7" name="TextBox 6"/>
-          <p:cNvSpPr txBox="1"/>
-          <p:nvPr/>
-        </p:nvSpPr>
-        <p:spPr>
-          <a:xfrm>
-            <a:off x="731520" y="2103120"/>
-            <a:ext cx="7772400" cy="365760"/>
-          </a:xfrm>
-          <a:prstGeom prst="rect">
-            <a:avLst/>
-          </a:prstGeom>
-          <a:noFill/>
-        </p:spPr>
-        <p:txBody>
-          <a:bodyPr wrap="none">
-            <a:spAutoFit/>
-          </a:bodyPr>
-          <a:lstStyle/>
-          <a:p>
-            <a:pPr>
-              <a:defRPr sz="1400">
-                <a:solidFill>
-                  <a:srgbClr val="666666"/>
-                </a:solidFill>
-              </a:defRPr>
-            </a:pPr>
-            <a:r>
-              <a:t>  - 데이터 소스와 벡터 DB 간의 접근 권한 정합성 검증</a:t>
-            </a:r>
-          </a:p>
-        </p:txBody>
-      </p:sp>
-      <p:sp>
-        <p:nvSpPr>
-          <p:cNvPr id="8" name="TextBox 7"/>
-          <p:cNvSpPr txBox="1"/>
-          <p:nvPr/>
-        </p:nvSpPr>
-        <p:spPr>
-          <a:xfrm>
-            <a:off x="731520" y="2377439"/>
-            <a:ext cx="7772400" cy="365760"/>
-          </a:xfrm>
-          <a:prstGeom prst="rect">
-            <a:avLst/>
-          </a:prstGeom>
-          <a:noFill/>
-        </p:spPr>
-        <p:txBody>
-          <a:bodyPr wrap="none">
-            <a:spAutoFit/>
-          </a:bodyPr>
-          <a:lstStyle/>
-          <a:p>
-            <a:pPr>
-              <a:defRPr sz="1400">
-                <a:solidFill>
-                  <a:srgbClr val="666666"/>
-                </a:solidFill>
-              </a:defRPr>
-            </a:pPr>
-            <a:r>
-              <a:t>  - 데이터 계보(Lineage) 추적을 통한 사고 발생 시 즉시 격리</a:t>
+              <a:t>• 단순 정책 수립을 넘어선 '실시간 기술적 강제(Runtime Enforcement)' 기반의 초격차 거버넌스 제공</a:t>
             </a:r>
           </a:p>
         </p:txBody>
@@ -4839,14 +5238,14 @@
           <a:lstStyle/>
           <a:p>
             <a:pPr>
-              <a:defRPr b="1" sz="2800">
-                <a:solidFill>
-                  <a:srgbClr val="1F1F1F"/>
+              <a:defRPr b="1" sz="2400">
+                <a:solidFill>
+                  <a:srgbClr val="0F172A"/>
                 </a:solidFill>
               </a:defRPr>
             </a:pPr>
             <a:r>
-              <a:t>전략 Pillar 2: Agent-SPM (Killer Item)</a:t>
+              <a:t>시장의 페인포인트 및 위협 환경</a:t>
             </a:r>
           </a:p>
         </p:txBody>
@@ -4868,20 +5267,20 @@
           <a:noFill/>
         </p:spPr>
         <p:txBody>
-          <a:bodyPr wrap="none">
+          <a:bodyPr wrap="square">
             <a:spAutoFit/>
           </a:bodyPr>
           <a:lstStyle/>
           <a:p>
             <a:pPr>
-              <a:defRPr sz="1800">
+              <a:defRPr sz="1300">
                 <a:solidFill>
                   <a:srgbClr val="1F1F1F"/>
                 </a:solidFill>
               </a:defRPr>
             </a:pPr>
             <a:r>
-              <a:t>• 자율형 에이전트 행동 거버넌스 및 실시간 통제</a:t>
+              <a:t>• 입구 보안(North-South)의 한계: 내부 에이전트 간 통신(East-West) 보안 부재</a:t>
             </a:r>
           </a:p>
         </p:txBody>
@@ -4894,7 +5293,7 @@
         </p:nvSpPr>
         <p:spPr>
           <a:xfrm>
-            <a:off x="457200" y="1463040"/>
+            <a:off x="457200" y="1417319"/>
             <a:ext cx="8229600" cy="457200"/>
           </a:xfrm>
           <a:prstGeom prst="rect">
@@ -4903,20 +5302,20 @@
           <a:noFill/>
         </p:spPr>
         <p:txBody>
-          <a:bodyPr wrap="none">
+          <a:bodyPr wrap="square">
             <a:spAutoFit/>
           </a:bodyPr>
           <a:lstStyle/>
           <a:p>
             <a:pPr>
-              <a:defRPr sz="1800">
+              <a:defRPr sz="1300">
                 <a:solidFill>
                   <a:srgbClr val="1F1F1F"/>
                 </a:solidFill>
               </a:defRPr>
             </a:pPr>
             <a:r>
-              <a:t>• 핵심 차별화 포인트:</a:t>
+              <a:t>• 의미론적 우회(Semantic Evasion): 문맥을 이용한 지능형 프롬프트 인젝션 급증</a:t>
             </a:r>
           </a:p>
         </p:txBody>
@@ -4929,8 +5328,8 @@
         </p:nvSpPr>
         <p:spPr>
           <a:xfrm>
-            <a:off x="731520" y="1828800"/>
-            <a:ext cx="7772400" cy="365760"/>
+            <a:off x="457200" y="1737360"/>
+            <a:ext cx="8229600" cy="457200"/>
           </a:xfrm>
           <a:prstGeom prst="rect">
             <a:avLst/>
@@ -4938,20 +5337,20 @@
           <a:noFill/>
         </p:spPr>
         <p:txBody>
-          <a:bodyPr wrap="none">
+          <a:bodyPr wrap="square">
             <a:spAutoFit/>
           </a:bodyPr>
           <a:lstStyle/>
           <a:p>
             <a:pPr>
-              <a:defRPr sz="1400">
-                <a:solidFill>
-                  <a:srgbClr val="666666"/>
+              <a:defRPr sz="1300">
+                <a:solidFill>
+                  <a:srgbClr val="1F1F1F"/>
                 </a:solidFill>
               </a:defRPr>
             </a:pPr>
             <a:r>
-              <a:t>  - NHI(비인간 ID) 자산 관리: 에이전트별 최소 권한(PoLP) 강제</a:t>
+              <a:t>• AI 블랙박스 리스크: 의사결정 근거 불투명으로 인한 책임 소재 불분명</a:t>
             </a:r>
           </a:p>
         </p:txBody>
@@ -4964,8 +5363,8 @@
         </p:nvSpPr>
         <p:spPr>
           <a:xfrm>
-            <a:off x="731520" y="2103120"/>
-            <a:ext cx="7772400" cy="365760"/>
+            <a:off x="457200" y="2057400"/>
+            <a:ext cx="8229600" cy="457200"/>
           </a:xfrm>
           <a:prstGeom prst="rect">
             <a:avLst/>
@@ -4973,20 +5372,20 @@
           <a:noFill/>
         </p:spPr>
         <p:txBody>
-          <a:bodyPr wrap="none">
+          <a:bodyPr wrap="square">
             <a:spAutoFit/>
           </a:bodyPr>
           <a:lstStyle/>
           <a:p>
             <a:pPr>
-              <a:defRPr sz="1400">
-                <a:solidFill>
-                  <a:srgbClr val="666666"/>
+              <a:defRPr sz="1300">
+                <a:solidFill>
+                  <a:srgbClr val="1F1F1F"/>
                 </a:solidFill>
               </a:defRPr>
             </a:pPr>
             <a:r>
-              <a:t>  - Semantic Firewall: 에이전트의 추론 과정(CoT) 감시 및 차단</a:t>
+              <a:t>• 섀도우 AI &amp; 자산 방치: 관리되지 않는 모델 및 퇴역 모델 내 데이터 유출(Memory Leakage)</a:t>
             </a:r>
           </a:p>
         </p:txBody>
@@ -4999,8 +5398,8 @@
         </p:nvSpPr>
         <p:spPr>
           <a:xfrm>
-            <a:off x="731520" y="2377439"/>
-            <a:ext cx="7772400" cy="365760"/>
+            <a:off x="457200" y="2377440"/>
+            <a:ext cx="8229600" cy="457200"/>
           </a:xfrm>
           <a:prstGeom prst="rect">
             <a:avLst/>
@@ -5008,20 +5407,20 @@
           <a:noFill/>
         </p:spPr>
         <p:txBody>
-          <a:bodyPr wrap="none">
+          <a:bodyPr wrap="square">
             <a:spAutoFit/>
           </a:bodyPr>
           <a:lstStyle/>
           <a:p>
             <a:pPr>
-              <a:defRPr sz="1400">
-                <a:solidFill>
-                  <a:srgbClr val="666666"/>
+              <a:defRPr sz="1300">
+                <a:solidFill>
+                  <a:srgbClr val="1F1F1F"/>
                 </a:solidFill>
               </a:defRPr>
             </a:pPr>
             <a:r>
-              <a:t>  - 기계 간 통신(A2A) 셧다운 시스템: 에이전트 폭주 방어</a:t>
+              <a:t>• 규제 피로도: 금감원/KISA/EU AI Act 등 복잡해지는 글로벌 규제 대응 한계</a:t>
             </a:r>
           </a:p>
         </p:txBody>
@@ -5118,14 +5517,14 @@
           <a:lstStyle/>
           <a:p>
             <a:pPr>
-              <a:defRPr b="1" sz="2800">
-                <a:solidFill>
-                  <a:srgbClr val="1F1F1F"/>
+              <a:defRPr b="1" sz="2400">
+                <a:solidFill>
+                  <a:srgbClr val="0F172A"/>
                 </a:solidFill>
               </a:defRPr>
             </a:pPr>
             <a:r>
-              <a:t>현장 인사이트: 신한은행 미팅 기반 페인포인트 해결</a:t>
+              <a:t>경쟁 우위 분석 (2026 Competitive Edge)</a:t>
             </a:r>
           </a:p>
         </p:txBody>
@@ -5147,164 +5546,394 @@
           <a:noFill/>
         </p:spPr>
         <p:txBody>
-          <a:bodyPr wrap="none">
+          <a:bodyPr wrap="square">
             <a:spAutoFit/>
           </a:bodyPr>
           <a:lstStyle/>
           <a:p>
             <a:pPr>
-              <a:defRPr sz="1800">
+              <a:defRPr sz="1300">
                 <a:solidFill>
                   <a:srgbClr val="1F1F1F"/>
                 </a:solidFill>
               </a:defRPr>
             </a:pPr>
             <a:r>
-              <a:t>• 행정 지옥 해소: 망분리 5호 예외 지정을 위한 'PaaS 래핑' 아키텍처</a:t>
-            </a:r>
-          </a:p>
-        </p:txBody>
-      </p:sp>
-      <p:sp>
-        <p:nvSpPr>
-          <p:cNvPr id="5" name="TextBox 4"/>
-          <p:cNvSpPr txBox="1"/>
-          <p:nvPr/>
-        </p:nvSpPr>
-        <p:spPr>
-          <a:xfrm>
-            <a:off x="457200" y="1463040"/>
-            <a:ext cx="8229600" cy="457200"/>
-          </a:xfrm>
-          <a:prstGeom prst="rect">
-            <a:avLst/>
-          </a:prstGeom>
-          <a:noFill/>
-        </p:spPr>
-        <p:txBody>
-          <a:bodyPr wrap="none">
-            <a:spAutoFit/>
-          </a:bodyPr>
-          <a:lstStyle/>
-          <a:p>
-            <a:pPr>
-              <a:defRPr sz="1800">
-                <a:solidFill>
-                  <a:srgbClr val="1F1F1F"/>
-                </a:solidFill>
-              </a:defRPr>
-            </a:pPr>
-            <a:r>
-              <a:t>• 지능형 필터링: '공일공' 등 문맥적 우회 유출을 막는 Semantic DLP</a:t>
-            </a:r>
-          </a:p>
-        </p:txBody>
-      </p:sp>
-      <p:sp>
-        <p:nvSpPr>
-          <p:cNvPr id="6" name="TextBox 5"/>
-          <p:cNvSpPr txBox="1"/>
-          <p:nvPr/>
-        </p:nvSpPr>
-        <p:spPr>
-          <a:xfrm>
-            <a:off x="457200" y="1828800"/>
-            <a:ext cx="8229600" cy="457200"/>
-          </a:xfrm>
-          <a:prstGeom prst="rect">
-            <a:avLst/>
-          </a:prstGeom>
-          <a:noFill/>
-        </p:spPr>
-        <p:txBody>
-          <a:bodyPr wrap="none">
-            <a:spAutoFit/>
-          </a:bodyPr>
-          <a:lstStyle/>
-          <a:p>
-            <a:pPr>
-              <a:defRPr sz="1800">
-                <a:solidFill>
-                  <a:srgbClr val="1F1F1F"/>
-                </a:solidFill>
-              </a:defRPr>
-            </a:pPr>
-            <a:r>
-              <a:t>• 실무 효율화:</a:t>
-            </a:r>
-          </a:p>
-        </p:txBody>
-      </p:sp>
-      <p:sp>
-        <p:nvSpPr>
-          <p:cNvPr id="7" name="TextBox 6"/>
-          <p:cNvSpPr txBox="1"/>
-          <p:nvPr/>
-        </p:nvSpPr>
-        <p:spPr>
-          <a:xfrm>
-            <a:off x="731520" y="2194560"/>
-            <a:ext cx="7772400" cy="365760"/>
-          </a:xfrm>
-          <a:prstGeom prst="rect">
-            <a:avLst/>
-          </a:prstGeom>
-          <a:noFill/>
-        </p:spPr>
-        <p:txBody>
-          <a:bodyPr wrap="none">
-            <a:spAutoFit/>
-          </a:bodyPr>
-          <a:lstStyle/>
-          <a:p>
-            <a:pPr>
-              <a:defRPr sz="1400">
-                <a:solidFill>
-                  <a:srgbClr val="666666"/>
-                </a:solidFill>
-              </a:defRPr>
-            </a:pPr>
-            <a:r>
-              <a:t>  - 금감원/감사 대응용 보안 증적 리포트 원클릭 자동 생성</a:t>
-            </a:r>
-          </a:p>
-        </p:txBody>
-      </p:sp>
-      <p:sp>
-        <p:nvSpPr>
-          <p:cNvPr id="8" name="TextBox 7"/>
-          <p:cNvSpPr txBox="1"/>
-          <p:nvPr/>
-        </p:nvSpPr>
-        <p:spPr>
-          <a:xfrm>
-            <a:off x="731520" y="2468879"/>
-            <a:ext cx="7772400" cy="365760"/>
-          </a:xfrm>
-          <a:prstGeom prst="rect">
-            <a:avLst/>
-          </a:prstGeom>
-          <a:noFill/>
-        </p:spPr>
-        <p:txBody>
-          <a:bodyPr wrap="none">
-            <a:spAutoFit/>
-          </a:bodyPr>
-          <a:lstStyle/>
-          <a:p>
-            <a:pPr>
-              <a:defRPr sz="1400">
-                <a:solidFill>
-                  <a:srgbClr val="666666"/>
-                </a:solidFill>
-              </a:defRPr>
-            </a:pPr>
-            <a:r>
-              <a:t>  - 1,000명 동시 접속 '트래픽 쓰나미' 안정적 스로틀링</a:t>
-            </a:r>
-          </a:p>
-        </p:txBody>
-      </p:sp>
+              <a:t>• 기존 Gateway 시장은 이미 레드오션화 되었으며, '행위(Behavior)' 중심의 Agent-SPM이 차세대 블루오션으로 부상</a:t>
+            </a:r>
+          </a:p>
+        </p:txBody>
+      </p:sp>
+      <p:graphicFrame>
+        <p:nvGraphicFramePr>
+          <p:cNvPr id="5" name="Table 4"/>
+          <p:cNvGraphicFramePr>
+            <a:graphicFrameLocks noGrp="1"/>
+          </p:cNvGraphicFramePr>
+          <p:nvPr/>
+        </p:nvGraphicFramePr>
+        <p:xfrm>
+          <a:off x="457200" y="1.7499999999999998"/>
+          <a:ext cx="8229600" cy="1371600"/>
+        </p:xfrm>
+        <a:graphic>
+          <a:graphicData uri="http://schemas.openxmlformats.org/drawingml/2006/table">
+            <a:tbl>
+              <a:tblPr firstRow="1" bandRow="1">
+                <a:tableStyleId>{5C22544A-7EE6-4342-B048-85BDC9FD1C3A}</a:tableStyleId>
+              </a:tblPr>
+              <a:tblGrid>
+                <a:gridCol w="2057400"/>
+                <a:gridCol w="2057400"/>
+                <a:gridCol w="2057400"/>
+                <a:gridCol w="2057400"/>
+              </a:tblGrid>
+              <a:tr h="274320">
+                <a:tc>
+                  <a:txBody>
+                    <a:bodyPr/>
+                    <a:lstStyle/>
+                    <a:p>
+                      <a:pPr>
+                        <a:defRPr sz="1000" b="1">
+                          <a:solidFill>
+                            <a:srgbClr val="FFFFFF"/>
+                          </a:solidFill>
+                        </a:defRPr>
+                      </a:pPr>
+                      <a:r>
+                        <a:t>구분</a:t>
+                      </a:r>
+                    </a:p>
+                  </a:txBody>
+                  <a:tcPr>
+                    <a:solidFill>
+                      <a:srgbClr val="7B3CE9"/>
+                    </a:solidFill>
+                  </a:tcPr>
+                </a:tc>
+                <a:tc>
+                  <a:txBody>
+                    <a:bodyPr/>
+                    <a:lstStyle/>
+                    <a:p>
+                      <a:pPr>
+                        <a:defRPr sz="1000" b="1">
+                          <a:solidFill>
+                            <a:srgbClr val="FFFFFF"/>
+                          </a:solidFill>
+                        </a:defRPr>
+                      </a:pPr>
+                      <a:r>
+                        <a:t>AI Gateway (Red Ocean)</a:t>
+                      </a:r>
+                    </a:p>
+                  </a:txBody>
+                  <a:tcPr>
+                    <a:solidFill>
+                      <a:srgbClr val="7B3CE9"/>
+                    </a:solidFill>
+                  </a:tcPr>
+                </a:tc>
+                <a:tc>
+                  <a:txBody>
+                    <a:bodyPr/>
+                    <a:lstStyle/>
+                    <a:p>
+                      <a:pPr>
+                        <a:defRPr sz="1000" b="1">
+                          <a:solidFill>
+                            <a:srgbClr val="FFFFFF"/>
+                          </a:solidFill>
+                        </a:defRPr>
+                      </a:pPr>
+                      <a:r>
+                        <a:t>AI-DSPM (Growing)</a:t>
+                      </a:r>
+                    </a:p>
+                  </a:txBody>
+                  <a:tcPr>
+                    <a:solidFill>
+                      <a:srgbClr val="7B3CE9"/>
+                    </a:solidFill>
+                  </a:tcPr>
+                </a:tc>
+                <a:tc>
+                  <a:txBody>
+                    <a:bodyPr/>
+                    <a:lstStyle/>
+                    <a:p>
+                      <a:pPr>
+                        <a:defRPr sz="1000" b="1">
+                          <a:solidFill>
+                            <a:srgbClr val="FFFFFF"/>
+                          </a:solidFill>
+                        </a:defRPr>
+                      </a:pPr>
+                      <a:r>
+                        <a:t>Agent-SPM (Blue Ocean)</a:t>
+                      </a:r>
+                    </a:p>
+                  </a:txBody>
+                  <a:tcPr>
+                    <a:solidFill>
+                      <a:srgbClr val="7B3CE9"/>
+                    </a:solidFill>
+                  </a:tcPr>
+                </a:tc>
+              </a:tr>
+              <a:tr h="274320">
+                <a:tc>
+                  <a:txBody>
+                    <a:bodyPr/>
+                    <a:lstStyle/>
+                    <a:p>
+                      <a:pPr>
+                        <a:defRPr sz="1000"/>
+                      </a:pPr>
+                      <a:r>
+                        <a:t>관점</a:t>
+                      </a:r>
+                    </a:p>
+                  </a:txBody>
+                  <a:tcPr/>
+                </a:tc>
+                <a:tc>
+                  <a:txBody>
+                    <a:bodyPr/>
+                    <a:lstStyle/>
+                    <a:p>
+                      <a:pPr>
+                        <a:defRPr sz="1000"/>
+                      </a:pPr>
+                      <a:r>
+                        <a:t>통로(Perimeter) 중심</a:t>
+                      </a:r>
+                    </a:p>
+                  </a:txBody>
+                  <a:tcPr/>
+                </a:tc>
+                <a:tc>
+                  <a:txBody>
+                    <a:bodyPr/>
+                    <a:lstStyle/>
+                    <a:p>
+                      <a:pPr>
+                        <a:defRPr sz="1000"/>
+                      </a:pPr>
+                      <a:r>
+                        <a:t>데이터(Storage) 중심</a:t>
+                      </a:r>
+                    </a:p>
+                  </a:txBody>
+                  <a:tcPr/>
+                </a:tc>
+                <a:tc>
+                  <a:txBody>
+                    <a:bodyPr/>
+                    <a:lstStyle/>
+                    <a:p>
+                      <a:pPr>
+                        <a:defRPr sz="1000"/>
+                      </a:pPr>
+                      <a:r>
+                        <a:t>행위(Behavior) 중심</a:t>
+                      </a:r>
+                    </a:p>
+                  </a:txBody>
+                  <a:tcPr/>
+                </a:tc>
+              </a:tr>
+              <a:tr h="274320">
+                <a:tc>
+                  <a:txBody>
+                    <a:bodyPr/>
+                    <a:lstStyle/>
+                    <a:p>
+                      <a:pPr>
+                        <a:defRPr sz="1000"/>
+                      </a:pPr>
+                      <a:r>
+                        <a:t>핵심 가치</a:t>
+                      </a:r>
+                    </a:p>
+                  </a:txBody>
+                  <a:tcPr/>
+                </a:tc>
+                <a:tc>
+                  <a:txBody>
+                    <a:bodyPr/>
+                    <a:lstStyle/>
+                    <a:p>
+                      <a:pPr>
+                        <a:defRPr sz="1000"/>
+                      </a:pPr>
+                      <a:r>
+                        <a:t>입구 차단, 속도 제한</a:t>
+                      </a:r>
+                    </a:p>
+                  </a:txBody>
+                  <a:tcPr/>
+                </a:tc>
+                <a:tc>
+                  <a:txBody>
+                    <a:bodyPr/>
+                    <a:lstStyle/>
+                    <a:p>
+                      <a:pPr>
+                        <a:defRPr sz="1000"/>
+                      </a:pPr>
+                      <a:r>
+                        <a:t>정보 유출 방지, 분류</a:t>
+                      </a:r>
+                    </a:p>
+                  </a:txBody>
+                  <a:tcPr/>
+                </a:tc>
+                <a:tc>
+                  <a:txBody>
+                    <a:bodyPr/>
+                    <a:lstStyle/>
+                    <a:p>
+                      <a:pPr>
+                        <a:defRPr sz="1000"/>
+                      </a:pPr>
+                      <a:r>
+                        <a:t>AI의 자율성 통제 및 책임</a:t>
+                      </a:r>
+                    </a:p>
+                  </a:txBody>
+                  <a:tcPr/>
+                </a:tc>
+              </a:tr>
+              <a:tr h="274320">
+                <a:tc>
+                  <a:txBody>
+                    <a:bodyPr/>
+                    <a:lstStyle/>
+                    <a:p>
+                      <a:pPr>
+                        <a:defRPr sz="1000"/>
+                      </a:pPr>
+                      <a:r>
+                        <a:t>진입 장벽</a:t>
+                      </a:r>
+                    </a:p>
+                  </a:txBody>
+                  <a:tcPr/>
+                </a:tc>
+                <a:tc>
+                  <a:txBody>
+                    <a:bodyPr/>
+                    <a:lstStyle/>
+                    <a:p>
+                      <a:pPr>
+                        <a:defRPr sz="1000"/>
+                      </a:pPr>
+                      <a:r>
+                        <a:t>낮음 (오픈소스 다수)</a:t>
+                      </a:r>
+                    </a:p>
+                  </a:txBody>
+                  <a:tcPr/>
+                </a:tc>
+                <a:tc>
+                  <a:txBody>
+                    <a:bodyPr/>
+                    <a:lstStyle/>
+                    <a:p>
+                      <a:pPr>
+                        <a:defRPr sz="1000"/>
+                      </a:pPr>
+                      <a:r>
+                        <a:t>중간 (기술 가시성)</a:t>
+                      </a:r>
+                    </a:p>
+                  </a:txBody>
+                  <a:tcPr/>
+                </a:tc>
+                <a:tc>
+                  <a:txBody>
+                    <a:bodyPr/>
+                    <a:lstStyle/>
+                    <a:p>
+                      <a:pPr>
+                        <a:defRPr sz="1000"/>
+                      </a:pPr>
+                      <a:r>
+                        <a:t>높음 (LLM 추론 분석)</a:t>
+                      </a:r>
+                    </a:p>
+                  </a:txBody>
+                  <a:tcPr/>
+                </a:tc>
+              </a:tr>
+              <a:tr h="274320">
+                <a:tc>
+                  <a:txBody>
+                    <a:bodyPr/>
+                    <a:lstStyle/>
+                    <a:p>
+                      <a:pPr>
+                        <a:defRPr sz="1000"/>
+                      </a:pPr>
+                      <a:r>
+                        <a:t>금융권 반응</a:t>
+                      </a:r>
+                    </a:p>
+                  </a:txBody>
+                  <a:tcPr/>
+                </a:tc>
+                <a:tc>
+                  <a:txBody>
+                    <a:bodyPr/>
+                    <a:lstStyle/>
+                    <a:p>
+                      <a:pPr>
+                        <a:defRPr sz="1000"/>
+                      </a:pPr>
+                      <a:r>
+                        <a:t>기본 인프라로 인식</a:t>
+                      </a:r>
+                    </a:p>
+                  </a:txBody>
+                  <a:tcPr/>
+                </a:tc>
+                <a:tc>
+                  <a:txBody>
+                    <a:bodyPr/>
+                    <a:lstStyle/>
+                    <a:p>
+                      <a:pPr>
+                        <a:defRPr sz="1000"/>
+                      </a:pPr>
+                      <a:r>
+                        <a:t>컴플라이언스 대응용</a:t>
+                      </a:r>
+                    </a:p>
+                  </a:txBody>
+                  <a:tcPr/>
+                </a:tc>
+                <a:tc>
+                  <a:txBody>
+                    <a:bodyPr/>
+                    <a:lstStyle/>
+                    <a:p>
+                      <a:pPr>
+                        <a:defRPr sz="1000"/>
+                      </a:pPr>
+                      <a:r>
+                        <a:t>AX 전면 도입을 위한 필수재</a:t>
+                      </a:r>
+                    </a:p>
+                  </a:txBody>
+                  <a:tcPr/>
+                </a:tc>
+              </a:tr>
+            </a:tbl>
+          </a:graphicData>
+        </a:graphic>
+      </p:graphicFrame>
     </p:spTree>
   </p:cSld>
   <p:clrMapOvr>
@@ -5397,28 +6026,52 @@
           <a:lstStyle/>
           <a:p>
             <a:pPr>
-              <a:defRPr b="1" sz="2800">
-                <a:solidFill>
-                  <a:srgbClr val="1F1F1F"/>
+              <a:defRPr b="1" sz="2400">
+                <a:solidFill>
+                  <a:srgbClr val="0F172A"/>
                 </a:solidFill>
               </a:defRPr>
             </a:pPr>
             <a:r>
-              <a:t>한국 시장 특화 전략 (K-Compliance)</a:t>
-            </a:r>
-          </a:p>
-        </p:txBody>
-      </p:sp>
-      <p:sp>
-        <p:nvSpPr>
-          <p:cNvPr id="4" name="TextBox 3"/>
+              <a:t>PART 2. Safe AI 3중 방어 체계 아키텍처</a:t>
+            </a:r>
+          </a:p>
+        </p:txBody>
+      </p:sp>
+      <p:pic>
+        <p:nvPicPr>
+          <p:cNvPr id="4" name="Picture 3" descr="ai_agent_reasoning_guardrail_1778200328140.png"/>
+          <p:cNvPicPr>
+            <a:picLocks noChangeAspect="1"/>
+          </p:cNvPicPr>
+          <p:nvPr/>
+        </p:nvPicPr>
+        <p:blipFill>
+          <a:blip r:embed="rId2"/>
+          <a:stretch>
+            <a:fillRect/>
+          </a:stretch>
+        </p:blipFill>
+        <p:spPr>
+          <a:xfrm>
+            <a:off x="4754880" y="1371600"/>
+            <a:ext cx="3931920" cy="3931920"/>
+          </a:xfrm>
+          <a:prstGeom prst="rect">
+            <a:avLst/>
+          </a:prstGeom>
+        </p:spPr>
+      </p:pic>
+      <p:sp>
+        <p:nvSpPr>
+          <p:cNvPr id="5" name="TextBox 4"/>
           <p:cNvSpPr txBox="1"/>
           <p:nvPr/>
         </p:nvSpPr>
         <p:spPr>
           <a:xfrm>
             <a:off x="457200" y="1097280"/>
-            <a:ext cx="8229600" cy="457200"/>
+            <a:ext cx="4114800" cy="365760"/>
           </a:xfrm>
           <a:prstGeom prst="rect">
             <a:avLst/>
@@ -5432,28 +6085,168 @@
           <a:lstStyle/>
           <a:p>
             <a:pPr>
-              <a:defRPr sz="1800">
+              <a:defRPr b="1" sz="1600">
+                <a:solidFill>
+                  <a:srgbClr val="7B3CE9"/>
+                </a:solidFill>
+              </a:defRPr>
+            </a:pPr>
+            <a:r>
+              <a:t>4단계 통합 보안 레이어</a:t>
+            </a:r>
+          </a:p>
+        </p:txBody>
+      </p:sp>
+      <p:sp>
+        <p:nvSpPr>
+          <p:cNvPr id="6" name="TextBox 5"/>
+          <p:cNvSpPr txBox="1"/>
+          <p:nvPr/>
+        </p:nvSpPr>
+        <p:spPr>
+          <a:xfrm>
+            <a:off x="457200" y="1463040"/>
+            <a:ext cx="4114800" cy="457200"/>
+          </a:xfrm>
+          <a:prstGeom prst="rect">
+            <a:avLst/>
+          </a:prstGeom>
+          <a:noFill/>
+        </p:spPr>
+        <p:txBody>
+          <a:bodyPr wrap="square">
+            <a:spAutoFit/>
+          </a:bodyPr>
+          <a:lstStyle/>
+          <a:p>
+            <a:pPr>
+              <a:defRPr sz="1300">
                 <a:solidFill>
                   <a:srgbClr val="1F1F1F"/>
                 </a:solidFill>
               </a:defRPr>
             </a:pPr>
             <a:r>
-              <a:t>• 망분리 완화 로드맵 대응: 하이브리드(내부/외부) 보안 브릿지 제공</a:t>
-            </a:r>
-          </a:p>
-        </p:txBody>
-      </p:sp>
-      <p:sp>
-        <p:nvSpPr>
-          <p:cNvPr id="5" name="TextBox 4"/>
+              <a:t>• LAYER 1: 인바운드 게이트웨이 (DLP, 쿼터, 서킷브레이커)</a:t>
+            </a:r>
+          </a:p>
+        </p:txBody>
+      </p:sp>
+      <p:sp>
+        <p:nvSpPr>
+          <p:cNvPr id="7" name="TextBox 6"/>
           <p:cNvSpPr txBox="1"/>
           <p:nvPr/>
         </p:nvSpPr>
         <p:spPr>
           <a:xfrm>
-            <a:off x="457200" y="1463040"/>
-            <a:ext cx="8229600" cy="457200"/>
+            <a:off x="457200" y="1783080"/>
+            <a:ext cx="4114800" cy="457200"/>
+          </a:xfrm>
+          <a:prstGeom prst="rect">
+            <a:avLst/>
+          </a:prstGeom>
+          <a:noFill/>
+        </p:spPr>
+        <p:txBody>
+          <a:bodyPr wrap="square">
+            <a:spAutoFit/>
+          </a:bodyPr>
+          <a:lstStyle/>
+          <a:p>
+            <a:pPr>
+              <a:defRPr sz="1300">
+                <a:solidFill>
+                  <a:srgbClr val="1F1F1F"/>
+                </a:solidFill>
+              </a:defRPr>
+            </a:pPr>
+            <a:r>
+              <a:t>• LAYER 2: 에이전트 추론 감시 (CoT 인터셉트, Shadow Reasoning)</a:t>
+            </a:r>
+          </a:p>
+        </p:txBody>
+      </p:sp>
+      <p:sp>
+        <p:nvSpPr>
+          <p:cNvPr id="8" name="TextBox 7"/>
+          <p:cNvSpPr txBox="1"/>
+          <p:nvPr/>
+        </p:nvSpPr>
+        <p:spPr>
+          <a:xfrm>
+            <a:off x="457200" y="2103120"/>
+            <a:ext cx="4114800" cy="457200"/>
+          </a:xfrm>
+          <a:prstGeom prst="rect">
+            <a:avLst/>
+          </a:prstGeom>
+          <a:noFill/>
+        </p:spPr>
+        <p:txBody>
+          <a:bodyPr wrap="square">
+            <a:spAutoFit/>
+          </a:bodyPr>
+          <a:lstStyle/>
+          <a:p>
+            <a:pPr>
+              <a:defRPr sz="1300">
+                <a:solidFill>
+                  <a:srgbClr val="1F1F1F"/>
+                </a:solidFill>
+              </a:defRPr>
+            </a:pPr>
+            <a:r>
+              <a:t>• LAYER 3: 데이터 및 RAG 보안 (PII 마스킹, 안티 포이즈닝)</a:t>
+            </a:r>
+          </a:p>
+        </p:txBody>
+      </p:sp>
+      <p:sp>
+        <p:nvSpPr>
+          <p:cNvPr id="9" name="TextBox 8"/>
+          <p:cNvSpPr txBox="1"/>
+          <p:nvPr/>
+        </p:nvSpPr>
+        <p:spPr>
+          <a:xfrm>
+            <a:off x="457200" y="2423160"/>
+            <a:ext cx="4114800" cy="457200"/>
+          </a:xfrm>
+          <a:prstGeom prst="rect">
+            <a:avLst/>
+          </a:prstGeom>
+          <a:noFill/>
+        </p:spPr>
+        <p:txBody>
+          <a:bodyPr wrap="square">
+            <a:spAutoFit/>
+          </a:bodyPr>
+          <a:lstStyle/>
+          <a:p>
+            <a:pPr>
+              <a:defRPr sz="1300">
+                <a:solidFill>
+                  <a:srgbClr val="1F1F1F"/>
+                </a:solidFill>
+              </a:defRPr>
+            </a:pPr>
+            <a:r>
+              <a:t>• LAYER 4: 거버넌스 및 자산 생애주기 (자동 보고, 완전 파기)</a:t>
+            </a:r>
+          </a:p>
+        </p:txBody>
+      </p:sp>
+      <p:sp>
+        <p:nvSpPr>
+          <p:cNvPr id="10" name="TextBox 9"/>
+          <p:cNvSpPr txBox="1"/>
+          <p:nvPr/>
+        </p:nvSpPr>
+        <p:spPr>
+          <a:xfrm>
+            <a:off x="457200" y="2743200"/>
+            <a:ext cx="4114800" cy="365760"/>
           </a:xfrm>
           <a:prstGeom prst="rect">
             <a:avLst/>
@@ -5467,28 +6260,63 @@
           <a:lstStyle/>
           <a:p>
             <a:pPr>
-              <a:defRPr sz="1800">
+              <a:defRPr b="1" sz="1600">
+                <a:solidFill>
+                  <a:srgbClr val="7B3CE9"/>
+                </a:solidFill>
+              </a:defRPr>
+            </a:pPr>
+            <a:r>
+              <a:t>기술적 차별성</a:t>
+            </a:r>
+          </a:p>
+        </p:txBody>
+      </p:sp>
+      <p:sp>
+        <p:nvSpPr>
+          <p:cNvPr id="11" name="TextBox 10"/>
+          <p:cNvSpPr txBox="1"/>
+          <p:nvPr/>
+        </p:nvSpPr>
+        <p:spPr>
+          <a:xfrm>
+            <a:off x="457200" y="3108960"/>
+            <a:ext cx="4114800" cy="457200"/>
+          </a:xfrm>
+          <a:prstGeom prst="rect">
+            <a:avLst/>
+          </a:prstGeom>
+          <a:noFill/>
+        </p:spPr>
+        <p:txBody>
+          <a:bodyPr wrap="square">
+            <a:spAutoFit/>
+          </a:bodyPr>
+          <a:lstStyle/>
+          <a:p>
+            <a:pPr>
+              <a:defRPr sz="1300">
                 <a:solidFill>
                   <a:srgbClr val="1F1F1F"/>
                 </a:solidFill>
               </a:defRPr>
             </a:pPr>
             <a:r>
-              <a:t>• 혁신금융서비스 샌드박스 Accelerator:</a:t>
-            </a:r>
-          </a:p>
-        </p:txBody>
-      </p:sp>
-      <p:sp>
-        <p:nvSpPr>
-          <p:cNvPr id="6" name="TextBox 5"/>
+              <a:t>• East-West 통신 보안: 에이전트 간(A2A) 및 외부 도구 호출 실시간 모니터링</a:t>
+            </a:r>
+          </a:p>
+        </p:txBody>
+      </p:sp>
+      <p:sp>
+        <p:nvSpPr>
+          <p:cNvPr id="12" name="TextBox 11"/>
           <p:cNvSpPr txBox="1"/>
           <p:nvPr/>
         </p:nvSpPr>
         <p:spPr>
           <a:xfrm>
-            <a:off x="731520" y="1828800"/>
-            <a:ext cx="7772400" cy="365760"/>
+            <a:off x="457200" y="3429000"/>
+            <a:ext cx="4114800" cy="457200"/>
           </a:xfrm>
           <a:prstGeom prst="rect">
             <a:avLst/>
@@ -5496,55 +6324,20 @@
           <a:noFill/>
         </p:spPr>
         <p:txBody>
-          <a:bodyPr wrap="none">
+          <a:bodyPr wrap="square">
             <a:spAutoFit/>
           </a:bodyPr>
           <a:lstStyle/>
           <a:p>
             <a:pPr>
-              <a:defRPr sz="1400">
-                <a:solidFill>
-                  <a:srgbClr val="666666"/>
+              <a:defRPr sz="1300">
+                <a:solidFill>
+                  <a:srgbClr val="1F1F1F"/>
                 </a:solidFill>
               </a:defRPr>
             </a:pPr>
             <a:r>
-              <a:t>  - 심사 통과를 위한 보안 검증 패키지 턴키 제공</a:t>
-            </a:r>
-          </a:p>
-        </p:txBody>
-      </p:sp>
-      <p:sp>
-        <p:nvSpPr>
-          <p:cNvPr id="7" name="TextBox 6"/>
-          <p:cNvSpPr txBox="1"/>
-          <p:nvPr/>
-        </p:nvSpPr>
-        <p:spPr>
-          <a:xfrm>
-            <a:off x="731520" y="2103120"/>
-            <a:ext cx="7772400" cy="365760"/>
-          </a:xfrm>
-          <a:prstGeom prst="rect">
-            <a:avLst/>
-          </a:prstGeom>
-          <a:noFill/>
-        </p:spPr>
-        <p:txBody>
-          <a:bodyPr wrap="none">
-            <a:spAutoFit/>
-          </a:bodyPr>
-          <a:lstStyle/>
-          <a:p>
-            <a:pPr>
-              <a:defRPr sz="1400">
-                <a:solidFill>
-                  <a:srgbClr val="666666"/>
-                </a:solidFill>
-              </a:defRPr>
-            </a:pPr>
-            <a:r>
-              <a:t>  - 자율보안 체계 하에서의 '결과 책임' 방어권 확보</a:t>
+              <a:t>• 증명 가능한 지능: 추론 근거 전수 기록 및 규제 리포팅 자동화</a:t>
             </a:r>
           </a:p>
         </p:txBody>
@@ -5641,14 +6434,14 @@
           <a:lstStyle/>
           <a:p>
             <a:pPr>
-              <a:defRPr b="1" sz="2800">
-                <a:solidFill>
-                  <a:srgbClr val="1F1F1F"/>
+              <a:defRPr b="1" sz="2400">
+                <a:solidFill>
+                  <a:srgbClr val="0F172A"/>
                 </a:solidFill>
               </a:defRPr>
             </a:pPr>
             <a:r>
-              <a:t>경쟁 우위: 왜 Agent-SPM 인가?</a:t>
+              <a:t>핵심 기술: CoT 실시간 감시 및 Shadow Reasoning</a:t>
             </a:r>
           </a:p>
         </p:txBody>
@@ -5662,7 +6455,7 @@
         <p:spPr>
           <a:xfrm>
             <a:off x="457200" y="1097280"/>
-            <a:ext cx="8229600" cy="457200"/>
+            <a:ext cx="8229600" cy="365760"/>
           </a:xfrm>
           <a:prstGeom prst="rect">
             <a:avLst/>
@@ -5676,14 +6469,14 @@
           <a:lstStyle/>
           <a:p>
             <a:pPr>
-              <a:defRPr sz="1800">
-                <a:solidFill>
-                  <a:srgbClr val="1F1F1F"/>
+              <a:defRPr b="1" sz="1600">
+                <a:solidFill>
+                  <a:srgbClr val="7B3CE9"/>
                 </a:solidFill>
               </a:defRPr>
             </a:pPr>
             <a:r>
-              <a:t>• Gateway(외산 벤더): 트래픽 관리는 잘하나 한국 규제 및 AI 문맥 이해 부족</a:t>
+              <a:t>왜 입구(Prompt) 보안만으로는 부족한가?</a:t>
             </a:r>
           </a:p>
         </p:txBody>
@@ -5705,90 +6498,90 @@
           <a:noFill/>
         </p:spPr>
         <p:txBody>
+          <a:bodyPr wrap="square">
+            <a:spAutoFit/>
+          </a:bodyPr>
+          <a:lstStyle/>
+          <a:p>
+            <a:pPr>
+              <a:defRPr sz="1300">
+                <a:solidFill>
+                  <a:srgbClr val="1F1F1F"/>
+                </a:solidFill>
+              </a:defRPr>
+            </a:pPr>
+            <a:r>
+              <a:t>• 간접 인젝션(Indirect Injection): 정상 요청 속에 숨겨진 악의적 지시는 추론 과정에서만 포착 가능</a:t>
+            </a:r>
+          </a:p>
+        </p:txBody>
+      </p:sp>
+      <p:sp>
+        <p:nvSpPr>
+          <p:cNvPr id="6" name="TextBox 5"/>
+          <p:cNvSpPr txBox="1"/>
+          <p:nvPr/>
+        </p:nvSpPr>
+        <p:spPr>
+          <a:xfrm>
+            <a:off x="457200" y="1783080"/>
+            <a:ext cx="8229600" cy="457200"/>
+          </a:xfrm>
+          <a:prstGeom prst="rect">
+            <a:avLst/>
+          </a:prstGeom>
+          <a:noFill/>
+        </p:spPr>
+        <p:txBody>
+          <a:bodyPr wrap="square">
+            <a:spAutoFit/>
+          </a:bodyPr>
+          <a:lstStyle/>
+          <a:p>
+            <a:pPr>
+              <a:defRPr sz="1300">
+                <a:solidFill>
+                  <a:srgbClr val="1F1F1F"/>
+                </a:solidFill>
+              </a:defRPr>
+            </a:pPr>
+            <a:r>
+              <a:t>• 논리적 비약 방지: AI가 스스로 보안 절차를 생략하거나 규정을 우회하는 결정 차단</a:t>
+            </a:r>
+          </a:p>
+        </p:txBody>
+      </p:sp>
+      <p:sp>
+        <p:nvSpPr>
+          <p:cNvPr id="7" name="TextBox 6"/>
+          <p:cNvSpPr txBox="1"/>
+          <p:nvPr/>
+        </p:nvSpPr>
+        <p:spPr>
+          <a:xfrm>
+            <a:off x="457200" y="2103120"/>
+            <a:ext cx="8229600" cy="365760"/>
+          </a:xfrm>
+          <a:prstGeom prst="rect">
+            <a:avLst/>
+          </a:prstGeom>
+          <a:noFill/>
+        </p:spPr>
+        <p:txBody>
           <a:bodyPr wrap="none">
             <a:spAutoFit/>
           </a:bodyPr>
           <a:lstStyle/>
           <a:p>
             <a:pPr>
-              <a:defRPr sz="1800">
-                <a:solidFill>
-                  <a:srgbClr val="1F1F1F"/>
+              <a:defRPr b="1" sz="1600">
+                <a:solidFill>
+                  <a:srgbClr val="7B3CE9"/>
                 </a:solidFill>
               </a:defRPr>
             </a:pPr>
             <a:r>
-              <a:t>• DSPM(데이터 보안): 유출 방지는 하나 자율형 에이전트의 행위 통제 불가</a:t>
-            </a:r>
-          </a:p>
-        </p:txBody>
-      </p:sp>
-      <p:sp>
-        <p:nvSpPr>
-          <p:cNvPr id="6" name="TextBox 5"/>
-          <p:cNvSpPr txBox="1"/>
-          <p:nvPr/>
-        </p:nvSpPr>
-        <p:spPr>
-          <a:xfrm>
-            <a:off x="457200" y="1828800"/>
-            <a:ext cx="8229600" cy="457200"/>
-          </a:xfrm>
-          <a:prstGeom prst="rect">
-            <a:avLst/>
-          </a:prstGeom>
-          <a:noFill/>
-        </p:spPr>
-        <p:txBody>
-          <a:bodyPr wrap="none">
-            <a:spAutoFit/>
-          </a:bodyPr>
-          <a:lstStyle/>
-          <a:p>
-            <a:pPr>
-              <a:defRPr sz="1800">
-                <a:solidFill>
-                  <a:srgbClr val="1F1F1F"/>
-                </a:solidFill>
-              </a:defRPr>
-            </a:pPr>
-            <a:r>
-              <a:t>• Agent-SPM(U+):</a:t>
-            </a:r>
-          </a:p>
-        </p:txBody>
-      </p:sp>
-      <p:sp>
-        <p:nvSpPr>
-          <p:cNvPr id="7" name="TextBox 6"/>
-          <p:cNvSpPr txBox="1"/>
-          <p:nvPr/>
-        </p:nvSpPr>
-        <p:spPr>
-          <a:xfrm>
-            <a:off x="731520" y="2194560"/>
-            <a:ext cx="7772400" cy="365760"/>
-          </a:xfrm>
-          <a:prstGeom prst="rect">
-            <a:avLst/>
-          </a:prstGeom>
-          <a:noFill/>
-        </p:spPr>
-        <p:txBody>
-          <a:bodyPr wrap="none">
-            <a:spAutoFit/>
-          </a:bodyPr>
-          <a:lstStyle/>
-          <a:p>
-            <a:pPr>
-              <a:defRPr sz="1400">
-                <a:solidFill>
-                  <a:srgbClr val="666666"/>
-                </a:solidFill>
-              </a:defRPr>
-            </a:pPr>
-            <a:r>
-              <a:t>  - 국내 유일의 망분리 우회 컨설팅 결합</a:t>
+              <a:t>3단계 가드레일 메커니즘</a:t>
             </a:r>
           </a:p>
         </p:txBody>
@@ -5801,8 +6594,8 @@
         </p:nvSpPr>
         <p:spPr>
           <a:xfrm>
-            <a:off x="731520" y="2468879"/>
-            <a:ext cx="7772400" cy="365760"/>
+            <a:off x="457200" y="2468880"/>
+            <a:ext cx="8229600" cy="457200"/>
           </a:xfrm>
           <a:prstGeom prst="rect">
             <a:avLst/>
@@ -5810,20 +6603,90 @@
           <a:noFill/>
         </p:spPr>
         <p:txBody>
-          <a:bodyPr wrap="none">
+          <a:bodyPr wrap="square">
             <a:spAutoFit/>
           </a:bodyPr>
           <a:lstStyle/>
           <a:p>
             <a:pPr>
-              <a:defRPr sz="1400">
-                <a:solidFill>
-                  <a:srgbClr val="666666"/>
+              <a:defRPr sz="1300">
+                <a:solidFill>
+                  <a:srgbClr val="1F1F1F"/>
                 </a:solidFill>
               </a:defRPr>
             </a:pPr>
             <a:r>
-              <a:t>  - AI의 자율성을 통제하는 독보적 런타임 보안 기술</a:t>
+              <a:t>• 1. 강제적 사고 노출 (Enforced Disclosure): &lt;thought&gt; 태그 내 추론 텍스트화</a:t>
+            </a:r>
+          </a:p>
+        </p:txBody>
+      </p:sp>
+      <p:sp>
+        <p:nvSpPr>
+          <p:cNvPr id="9" name="TextBox 8"/>
+          <p:cNvSpPr txBox="1"/>
+          <p:nvPr/>
+        </p:nvSpPr>
+        <p:spPr>
+          <a:xfrm>
+            <a:off x="457200" y="2788920"/>
+            <a:ext cx="8229600" cy="457200"/>
+          </a:xfrm>
+          <a:prstGeom prst="rect">
+            <a:avLst/>
+          </a:prstGeom>
+          <a:noFill/>
+        </p:spPr>
+        <p:txBody>
+          <a:bodyPr wrap="square">
+            <a:spAutoFit/>
+          </a:bodyPr>
+          <a:lstStyle/>
+          <a:p>
+            <a:pPr>
+              <a:defRPr sz="1300">
+                <a:solidFill>
+                  <a:srgbClr val="1F1F1F"/>
+                </a:solidFill>
+              </a:defRPr>
+            </a:pPr>
+            <a:r>
+              <a:t>• 2. 실시간 토큰 인터셉트: 생성 즉시 게이트웨이 레벨 가로채기</a:t>
+            </a:r>
+          </a:p>
+        </p:txBody>
+      </p:sp>
+      <p:sp>
+        <p:nvSpPr>
+          <p:cNvPr id="10" name="TextBox 9"/>
+          <p:cNvSpPr txBox="1"/>
+          <p:nvPr/>
+        </p:nvSpPr>
+        <p:spPr>
+          <a:xfrm>
+            <a:off x="457200" y="3108960"/>
+            <a:ext cx="8229600" cy="457200"/>
+          </a:xfrm>
+          <a:prstGeom prst="rect">
+            <a:avLst/>
+          </a:prstGeom>
+          <a:noFill/>
+        </p:spPr>
+        <p:txBody>
+          <a:bodyPr wrap="square">
+            <a:spAutoFit/>
+          </a:bodyPr>
+          <a:lstStyle/>
+          <a:p>
+            <a:pPr>
+              <a:defRPr sz="1300">
+                <a:solidFill>
+                  <a:srgbClr val="1F1F1F"/>
+                </a:solidFill>
+              </a:defRPr>
+            </a:pPr>
+            <a:r>
+              <a:t>• 3. 그림자 추론 검증 (Shadow Reasoning): 별도 경량 sLLM을 통한 실시간 스캔 및 Kill-Switch</a:t>
             </a:r>
           </a:p>
         </p:txBody>
@@ -5920,14 +6783,14 @@
           <a:lstStyle/>
           <a:p>
             <a:pPr>
-              <a:defRPr b="1" sz="2800">
-                <a:solidFill>
-                  <a:srgbClr val="1F1F1F"/>
+              <a:defRPr b="1" sz="2400">
+                <a:solidFill>
+                  <a:srgbClr val="0F172A"/>
                 </a:solidFill>
               </a:defRPr>
             </a:pPr>
             <a:r>
-              <a:t>정부 가이드라인(AI 보안 안내서) 대응 전략</a:t>
+              <a:t>한국형 특화 보안 및 성능 전략</a:t>
             </a:r>
           </a:p>
         </p:txBody>
@@ -5941,7 +6804,7 @@
         <p:spPr>
           <a:xfrm>
             <a:off x="457200" y="1097280"/>
-            <a:ext cx="8229600" cy="457200"/>
+            <a:ext cx="8229600" cy="365760"/>
           </a:xfrm>
           <a:prstGeom prst="rect">
             <a:avLst/>
@@ -5955,14 +6818,14 @@
           <a:lstStyle/>
           <a:p>
             <a:pPr>
-              <a:defRPr sz="1800">
-                <a:solidFill>
-                  <a:srgbClr val="1F1F1F"/>
+              <a:defRPr b="1" sz="1600">
+                <a:solidFill>
+                  <a:srgbClr val="7B3CE9"/>
                 </a:solidFill>
               </a:defRPr>
             </a:pPr>
             <a:r>
-              <a:t>• Anti-Poisoning: 학습 데이터 오염 및 AI 편향성 실시간 차단</a:t>
+              <a:t>K-Compliance Strategy</a:t>
             </a:r>
           </a:p>
         </p:txBody>
@@ -5984,33 +6847,138 @@
           <a:noFill/>
         </p:spPr>
         <p:txBody>
+          <a:bodyPr wrap="square">
+            <a:spAutoFit/>
+          </a:bodyPr>
+          <a:lstStyle/>
+          <a:p>
+            <a:pPr>
+              <a:defRPr sz="1300">
+                <a:solidFill>
+                  <a:srgbClr val="1F1F1F"/>
+                </a:solidFill>
+              </a:defRPr>
+            </a:pPr>
+            <a:r>
+              <a:t>• 망분리 5호 예외 지원: U+ 인프라 내 PaaS 래핑 구조를 통한 샌드박스 우회</a:t>
+            </a:r>
+          </a:p>
+        </p:txBody>
+      </p:sp>
+      <p:sp>
+        <p:nvSpPr>
+          <p:cNvPr id="6" name="TextBox 5"/>
+          <p:cNvSpPr txBox="1"/>
+          <p:nvPr/>
+        </p:nvSpPr>
+        <p:spPr>
+          <a:xfrm>
+            <a:off x="457200" y="1783080"/>
+            <a:ext cx="8229600" cy="457200"/>
+          </a:xfrm>
+          <a:prstGeom prst="rect">
+            <a:avLst/>
+          </a:prstGeom>
+          <a:noFill/>
+        </p:spPr>
+        <p:txBody>
+          <a:bodyPr wrap="square">
+            <a:spAutoFit/>
+          </a:bodyPr>
+          <a:lstStyle/>
+          <a:p>
+            <a:pPr>
+              <a:defRPr sz="1300">
+                <a:solidFill>
+                  <a:srgbClr val="1F1F1F"/>
+                </a:solidFill>
+              </a:defRPr>
+            </a:pPr>
+            <a:r>
+              <a:t>• 행정 자동화: 금감원 가이드라인 맞춤형 '보안 사고 방어 일지' 원클릭 생성</a:t>
+            </a:r>
+          </a:p>
+        </p:txBody>
+      </p:sp>
+      <p:sp>
+        <p:nvSpPr>
+          <p:cNvPr id="7" name="TextBox 6"/>
+          <p:cNvSpPr txBox="1"/>
+          <p:nvPr/>
+        </p:nvSpPr>
+        <p:spPr>
+          <a:xfrm>
+            <a:off x="457200" y="2103120"/>
+            <a:ext cx="8229600" cy="365760"/>
+          </a:xfrm>
+          <a:prstGeom prst="rect">
+            <a:avLst/>
+          </a:prstGeom>
+          <a:noFill/>
+        </p:spPr>
+        <p:txBody>
           <a:bodyPr wrap="none">
             <a:spAutoFit/>
           </a:bodyPr>
           <a:lstStyle/>
           <a:p>
             <a:pPr>
-              <a:defRPr sz="1800">
+              <a:defRPr b="1" sz="1600">
+                <a:solidFill>
+                  <a:srgbClr val="7B3CE9"/>
+                </a:solidFill>
+              </a:defRPr>
+            </a:pPr>
+            <a:r>
+              <a:t>Performance Optimization</a:t>
+            </a:r>
+          </a:p>
+        </p:txBody>
+      </p:sp>
+      <p:sp>
+        <p:nvSpPr>
+          <p:cNvPr id="8" name="TextBox 7"/>
+          <p:cNvSpPr txBox="1"/>
+          <p:nvPr/>
+        </p:nvSpPr>
+        <p:spPr>
+          <a:xfrm>
+            <a:off x="457200" y="2468880"/>
+            <a:ext cx="8229600" cy="457200"/>
+          </a:xfrm>
+          <a:prstGeom prst="rect">
+            <a:avLst/>
+          </a:prstGeom>
+          <a:noFill/>
+        </p:spPr>
+        <p:txBody>
+          <a:bodyPr wrap="square">
+            <a:spAutoFit/>
+          </a:bodyPr>
+          <a:lstStyle/>
+          <a:p>
+            <a:pPr>
+              <a:defRPr sz="1300">
                 <a:solidFill>
                   <a:srgbClr val="1F1F1F"/>
                 </a:solidFill>
               </a:defRPr>
             </a:pPr>
             <a:r>
-              <a:t>• Edge Security: AI 로봇/에지 기기의 무단 제어 및 탈취 방어</a:t>
-            </a:r>
-          </a:p>
-        </p:txBody>
-      </p:sp>
-      <p:sp>
-        <p:nvSpPr>
-          <p:cNvPr id="6" name="TextBox 5"/>
+              <a:t>• 스트리밍 비동기 분석: TTFT를 최소화하는 실시간 병렬 분석</a:t>
+            </a:r>
+          </a:p>
+        </p:txBody>
+      </p:sp>
+      <p:sp>
+        <p:nvSpPr>
+          <p:cNvPr id="9" name="TextBox 8"/>
           <p:cNvSpPr txBox="1"/>
           <p:nvPr/>
         </p:nvSpPr>
         <p:spPr>
           <a:xfrm>
-            <a:off x="457200" y="1828800"/>
+            <a:off x="457200" y="2788920"/>
             <a:ext cx="8229600" cy="457200"/>
           </a:xfrm>
           <a:prstGeom prst="rect">
@@ -6019,55 +6987,20 @@
           <a:noFill/>
         </p:spPr>
         <p:txBody>
-          <a:bodyPr wrap="none">
+          <a:bodyPr wrap="square">
             <a:spAutoFit/>
           </a:bodyPr>
           <a:lstStyle/>
           <a:p>
             <a:pPr>
-              <a:defRPr sz="1800">
+              <a:defRPr sz="1300">
                 <a:solidFill>
                   <a:srgbClr val="1F1F1F"/>
                 </a:solidFill>
               </a:defRPr>
             </a:pPr>
             <a:r>
-              <a:t>• AI-Audit: 가이드라인 권고 '지속적 모니터링 및 로깅' 요건 충족</a:t>
-            </a:r>
-          </a:p>
-        </p:txBody>
-      </p:sp>
-      <p:sp>
-        <p:nvSpPr>
-          <p:cNvPr id="7" name="TextBox 6"/>
-          <p:cNvSpPr txBox="1"/>
-          <p:nvPr/>
-        </p:nvSpPr>
-        <p:spPr>
-          <a:xfrm>
-            <a:off x="457200" y="2194560"/>
-            <a:ext cx="8229600" cy="457200"/>
-          </a:xfrm>
-          <a:prstGeom prst="rect">
-            <a:avLst/>
-          </a:prstGeom>
-          <a:noFill/>
-        </p:spPr>
-        <p:txBody>
-          <a:bodyPr wrap="none">
-            <a:spAutoFit/>
-          </a:bodyPr>
-          <a:lstStyle/>
-          <a:p>
-            <a:pPr>
-              <a:defRPr sz="1800">
-                <a:solidFill>
-                  <a:srgbClr val="1F1F1F"/>
-                </a:solidFill>
-              </a:defRPr>
-            </a:pPr>
-            <a:r>
-              <a:t>• Result: 정부 지침을 100% 준수하는 '가장 안전한 금융 AI 인프라'</a:t>
+              <a:t>• 초경량 보안 가디언: 2B 이하 sLLM 배치로 연산 부하 5% 미만 유지</a:t>
             </a:r>
           </a:p>
         </p:txBody>
@@ -6164,28 +7097,52 @@
           <a:lstStyle/>
           <a:p>
             <a:pPr>
-              <a:defRPr b="1" sz="2800">
-                <a:solidFill>
-                  <a:srgbClr val="1F1F1F"/>
+              <a:defRPr b="1" sz="2400">
+                <a:solidFill>
+                  <a:srgbClr val="0F172A"/>
                 </a:solidFill>
               </a:defRPr>
             </a:pPr>
             <a:r>
-              <a:t>보안 담당자(CISO) 설득을 위한 Key Message</a:t>
-            </a:r>
-          </a:p>
-        </p:txBody>
-      </p:sp>
-      <p:sp>
-        <p:nvSpPr>
-          <p:cNvPr id="4" name="TextBox 3"/>
+              <a:t>AI 자산 생애주기 및 파기 (AI-Sanitizer)</a:t>
+            </a:r>
+          </a:p>
+        </p:txBody>
+      </p:sp>
+      <p:pic>
+        <p:nvPicPr>
+          <p:cNvPr id="4" name="Picture 3" descr="ai_lifecycle_governance_concept_1778200311426.png"/>
+          <p:cNvPicPr>
+            <a:picLocks noChangeAspect="1"/>
+          </p:cNvPicPr>
+          <p:nvPr/>
+        </p:nvPicPr>
+        <p:blipFill>
+          <a:blip r:embed="rId2"/>
+          <a:stretch>
+            <a:fillRect/>
+          </a:stretch>
+        </p:blipFill>
+        <p:spPr>
+          <a:xfrm>
+            <a:off x="4754880" y="1371600"/>
+            <a:ext cx="3931920" cy="3931920"/>
+          </a:xfrm>
+          <a:prstGeom prst="rect">
+            <a:avLst/>
+          </a:prstGeom>
+        </p:spPr>
+      </p:pic>
+      <p:sp>
+        <p:nvSpPr>
+          <p:cNvPr id="5" name="TextBox 4"/>
           <p:cNvSpPr txBox="1"/>
           <p:nvPr/>
         </p:nvSpPr>
         <p:spPr>
           <a:xfrm>
             <a:off x="457200" y="1097280"/>
-            <a:ext cx="8229600" cy="457200"/>
+            <a:ext cx="4114800" cy="365760"/>
           </a:xfrm>
           <a:prstGeom prst="rect">
             <a:avLst/>
@@ -6199,28 +7156,63 @@
           <a:lstStyle/>
           <a:p>
             <a:pPr>
-              <a:defRPr sz="1800">
+              <a:defRPr b="1" sz="1600">
+                <a:solidFill>
+                  <a:srgbClr val="7B3CE9"/>
+                </a:solidFill>
+              </a:defRPr>
+            </a:pPr>
+            <a:r>
+              <a:t>모델 퇴역 및 자산 소멸 전략</a:t>
+            </a:r>
+          </a:p>
+        </p:txBody>
+      </p:sp>
+      <p:sp>
+        <p:nvSpPr>
+          <p:cNvPr id="6" name="TextBox 5"/>
+          <p:cNvSpPr txBox="1"/>
+          <p:nvPr/>
+        </p:nvSpPr>
+        <p:spPr>
+          <a:xfrm>
+            <a:off x="457200" y="1463040"/>
+            <a:ext cx="4114800" cy="457200"/>
+          </a:xfrm>
+          <a:prstGeom prst="rect">
+            <a:avLst/>
+          </a:prstGeom>
+          <a:noFill/>
+        </p:spPr>
+        <p:txBody>
+          <a:bodyPr wrap="square">
+            <a:spAutoFit/>
+          </a:bodyPr>
+          <a:lstStyle/>
+          <a:p>
+            <a:pPr>
+              <a:defRPr sz="1300">
                 <a:solidFill>
                   <a:srgbClr val="1F1F1F"/>
                 </a:solidFill>
               </a:defRPr>
             </a:pPr>
             <a:r>
-              <a:t>• Accountability: AI 사고 발생 시 '면책 근거(Safe Harbor)' 제공</a:t>
-            </a:r>
-          </a:p>
-        </p:txBody>
-      </p:sp>
-      <p:sp>
-        <p:nvSpPr>
-          <p:cNvPr id="5" name="TextBox 4"/>
+              <a:t>• 문제: 모델 내 학습 데이터의 '메모리 현상(Memory Leakage)' 및 역공학 위협</a:t>
+            </a:r>
+          </a:p>
+        </p:txBody>
+      </p:sp>
+      <p:sp>
+        <p:nvSpPr>
+          <p:cNvPr id="7" name="TextBox 6"/>
           <p:cNvSpPr txBox="1"/>
           <p:nvPr/>
         </p:nvSpPr>
         <p:spPr>
           <a:xfrm>
-            <a:off x="457200" y="1463040"/>
-            <a:ext cx="8229600" cy="457200"/>
+            <a:off x="457200" y="1783080"/>
+            <a:ext cx="4114800" cy="365760"/>
           </a:xfrm>
           <a:prstGeom prst="rect">
             <a:avLst/>
@@ -6234,28 +7226,63 @@
           <a:lstStyle/>
           <a:p>
             <a:pPr>
-              <a:defRPr sz="1800">
+              <a:defRPr b="1" sz="1600">
+                <a:solidFill>
+                  <a:srgbClr val="7B3CE9"/>
+                </a:solidFill>
+              </a:defRPr>
+            </a:pPr>
+            <a:r>
+              <a:t>핵심 솔루션: AI-Sanitizer</a:t>
+            </a:r>
+          </a:p>
+        </p:txBody>
+      </p:sp>
+      <p:sp>
+        <p:nvSpPr>
+          <p:cNvPr id="8" name="TextBox 7"/>
+          <p:cNvSpPr txBox="1"/>
+          <p:nvPr/>
+        </p:nvSpPr>
+        <p:spPr>
+          <a:xfrm>
+            <a:off x="457200" y="2148840"/>
+            <a:ext cx="4114800" cy="457200"/>
+          </a:xfrm>
+          <a:prstGeom prst="rect">
+            <a:avLst/>
+          </a:prstGeom>
+          <a:noFill/>
+        </p:spPr>
+        <p:txBody>
+          <a:bodyPr wrap="square">
+            <a:spAutoFit/>
+          </a:bodyPr>
+          <a:lstStyle/>
+          <a:p>
+            <a:pPr>
+              <a:defRPr sz="1300">
                 <a:solidFill>
                   <a:srgbClr val="1F1F1F"/>
                 </a:solidFill>
               </a:defRPr>
             </a:pPr>
             <a:r>
-              <a:t>• Enabler: 혁신의 방해자가 아닌 '안전한 혁신(AX)의 조력자'로 위상 격상</a:t>
-            </a:r>
-          </a:p>
-        </p:txBody>
-      </p:sp>
-      <p:sp>
-        <p:nvSpPr>
-          <p:cNvPr id="6" name="TextBox 5"/>
+              <a:t>• 멀티레이어 와이핑(Wiping): GPU 메모리, 벡터 DB, 가중치 파일 완전 삭제</a:t>
+            </a:r>
+          </a:p>
+        </p:txBody>
+      </p:sp>
+      <p:sp>
+        <p:nvSpPr>
+          <p:cNvPr id="9" name="TextBox 8"/>
           <p:cNvSpPr txBox="1"/>
           <p:nvPr/>
         </p:nvSpPr>
         <p:spPr>
           <a:xfrm>
-            <a:off x="457200" y="1828800"/>
-            <a:ext cx="8229600" cy="457200"/>
+            <a:off x="457200" y="2468880"/>
+            <a:ext cx="4114800" cy="457200"/>
           </a:xfrm>
           <a:prstGeom prst="rect">
             <a:avLst/>
@@ -6263,34 +7290,34 @@
           <a:noFill/>
         </p:spPr>
         <p:txBody>
-          <a:bodyPr wrap="none">
+          <a:bodyPr wrap="square">
             <a:spAutoFit/>
           </a:bodyPr>
           <a:lstStyle/>
           <a:p>
             <a:pPr>
-              <a:defRPr sz="1800">
+              <a:defRPr sz="1300">
                 <a:solidFill>
                   <a:srgbClr val="1F1F1F"/>
                 </a:solidFill>
               </a:defRPr>
             </a:pPr>
             <a:r>
-              <a:t>• Asset Protection: 데이터 유출을 넘어 '직접적 재무 손실(환각/오작동)' 방어</a:t>
-            </a:r>
-          </a:p>
-        </p:txBody>
-      </p:sp>
-      <p:sp>
-        <p:nvSpPr>
-          <p:cNvPr id="7" name="TextBox 6"/>
+              <a:t>• 보안 파기 증명서: KISA 가이드라인 준수 증빙 리포트 자동 생성</a:t>
+            </a:r>
+          </a:p>
+        </p:txBody>
+      </p:sp>
+      <p:sp>
+        <p:nvSpPr>
+          <p:cNvPr id="10" name="TextBox 9"/>
           <p:cNvSpPr txBox="1"/>
           <p:nvPr/>
         </p:nvSpPr>
         <p:spPr>
           <a:xfrm>
-            <a:off x="457200" y="2194560"/>
-            <a:ext cx="8229600" cy="457200"/>
+            <a:off x="457200" y="2788920"/>
+            <a:ext cx="4114800" cy="457200"/>
           </a:xfrm>
           <a:prstGeom prst="rect">
             <a:avLst/>
@@ -6298,20 +7325,20 @@
           <a:noFill/>
         </p:spPr>
         <p:txBody>
-          <a:bodyPr wrap="none">
+          <a:bodyPr wrap="square">
             <a:spAutoFit/>
           </a:bodyPr>
           <a:lstStyle/>
           <a:p>
             <a:pPr>
-              <a:defRPr sz="1800">
+              <a:defRPr sz="1300">
                 <a:solidFill>
                   <a:srgbClr val="1F1F1F"/>
                 </a:solidFill>
               </a:defRPr>
             </a:pPr>
             <a:r>
-              <a:t>• Compliance: 행정 지옥(샌드박스/보고서)으로부터의 완전한 해방</a:t>
+              <a:t>• Lifecycle Dashboard: 전사 AI 자산 인벤토리 및 보안 드리프트 상시 감시</a:t>
             </a:r>
           </a:p>
         </p:txBody>

</xml_diff>